<commit_message>
update theming and add rudimentry header
</commit_message>
<xml_diff>
--- a/figma/MMI_Presentation.pptx
+++ b/figma/MMI_Presentation.pptx
@@ -8,8 +8,8 @@
     <p:sldId id="256" r:id="rId2"/>
     <p:sldId id="257" r:id="rId3"/>
     <p:sldId id="258" r:id="rId4"/>
-    <p:sldId id="259" r:id="rId5"/>
-    <p:sldId id="260" r:id="rId6"/>
+    <p:sldId id="274" r:id="rId5"/>
+    <p:sldId id="259" r:id="rId6"/>
     <p:sldId id="266" r:id="rId7"/>
     <p:sldId id="265" r:id="rId8"/>
     <p:sldId id="267" r:id="rId9"/>
@@ -9462,7 +9462,7 @@
           <a:p>
             <a:r>
               <a:rPr lang="en-US" dirty="0"/>
-              <a:t>Prettier (VS Code Auto formats code e.g. keep consistent single quote or double quote usage) </a:t>
+              <a:t>Prettier (Auto formats code e.g. keep consistent single quote or double quote usage) </a:t>
             </a:r>
           </a:p>
         </p:txBody>
@@ -10882,6 +10882,13 @@
               <a:rPr lang="en-US" dirty="0"/>
               <a:t>Tech Stack</a:t>
             </a:r>
+            <a:br>
+              <a:rPr lang="en-US" dirty="0"/>
+            </a:br>
+            <a:r>
+              <a:rPr lang="en-US" dirty="0"/>
+              <a:t>Frontend</a:t>
+            </a:r>
           </a:p>
         </p:txBody>
       </p:sp>
@@ -11038,40 +11045,6 @@
               <a:t>User auth using AWS Amplify + Cognito</a:t>
             </a:r>
           </a:p>
-          <a:p>
-            <a:r>
-              <a:rPr lang="en-US" sz="1900" dirty="0"/>
-              <a:t>Back End:</a:t>
-            </a:r>
-          </a:p>
-          <a:p>
-            <a:pPr lvl="1"/>
-            <a:r>
-              <a:rPr lang="en-US" sz="1900" dirty="0"/>
-              <a:t>NextJS (Api Routes)</a:t>
-            </a:r>
-          </a:p>
-          <a:p>
-            <a:pPr lvl="1"/>
-            <a:r>
-              <a:rPr lang="en-US" sz="1900" dirty="0"/>
-              <a:t>AWS S3 Buckets (file storage e.g. pictures, exported CVs)</a:t>
-            </a:r>
-          </a:p>
-          <a:p>
-            <a:pPr lvl="1"/>
-            <a:r>
-              <a:rPr lang="en-US" sz="1900" dirty="0"/>
-              <a:t>AWS DynamoDB (NoSQL database)</a:t>
-            </a:r>
-          </a:p>
-          <a:p>
-            <a:pPr lvl="1"/>
-            <a:r>
-              <a:rPr lang="en-US" sz="1900" dirty="0"/>
-              <a:t>AWS Cognito (User management and authentication</a:t>
-            </a:r>
-          </a:p>
         </p:txBody>
       </p:sp>
     </p:spTree>
@@ -11088,6 +11061,645 @@
 </file>
 
 <file path=ppt/slides/slide4.xml><?xml version="1.0" encoding="utf-8"?>
+<p:sld xmlns:a="http://schemas.openxmlformats.org/drawingml/2006/main" xmlns:r="http://schemas.openxmlformats.org/officeDocument/2006/relationships" xmlns:p="http://schemas.openxmlformats.org/presentationml/2006/main">
+  <p:cSld>
+    <p:bg>
+      <p:bgPr>
+        <a:solidFill>
+          <a:schemeClr val="bg1"/>
+        </a:solidFill>
+        <a:effectLst/>
+      </p:bgPr>
+    </p:bg>
+    <p:spTree>
+      <p:nvGrpSpPr>
+        <p:cNvPr id="1" name="">
+          <a:extLst>
+            <a:ext uri="{FF2B5EF4-FFF2-40B4-BE49-F238E27FC236}">
+              <a16:creationId xmlns:a16="http://schemas.microsoft.com/office/drawing/2014/main" id="{A4DC52E0-2855-5372-F444-252943EB2ACB}"/>
+            </a:ext>
+          </a:extLst>
+        </p:cNvPr>
+        <p:cNvGrpSpPr/>
+        <p:nvPr/>
+      </p:nvGrpSpPr>
+      <p:grpSpPr>
+        <a:xfrm>
+          <a:off x="0" y="0"/>
+          <a:ext cx="0" cy="0"/>
+          <a:chOff x="0" y="0"/>
+          <a:chExt cx="0" cy="0"/>
+        </a:xfrm>
+      </p:grpSpPr>
+      <p:sp useBgFill="1">
+        <p:nvSpPr>
+          <p:cNvPr id="8" name="Rectangle 7">
+            <a:extLst>
+              <a:ext uri="{FF2B5EF4-FFF2-40B4-BE49-F238E27FC236}">
+                <a16:creationId xmlns:a16="http://schemas.microsoft.com/office/drawing/2014/main" id="{41FFFFDA-CC39-2AFC-F285-352F5ED9454F}"/>
+              </a:ext>
+              <a:ext uri="{C183D7F6-B498-43B3-948B-1728B52AA6E4}">
+                <adec:decorative xmlns:adec="http://schemas.microsoft.com/office/drawing/2017/decorative" val="1"/>
+              </a:ext>
+            </a:extLst>
+          </p:cNvPr>
+          <p:cNvSpPr>
+            <a:spLocks noGrp="1" noRot="1" noChangeAspect="1" noMove="1" noResize="1" noEditPoints="1" noAdjustHandles="1" noChangeArrowheads="1" noChangeShapeType="1" noTextEdit="1"/>
+          </p:cNvSpPr>
+          <p:nvPr>
+            <p:extLst>
+              <p:ext uri="{386F3935-93C4-4BCD-93E2-E3B085C9AB24}">
+                <p16:designElem xmlns:p16="http://schemas.microsoft.com/office/powerpoint/2015/main" val="1"/>
+              </p:ext>
+            </p:extLst>
+          </p:nvPr>
+        </p:nvSpPr>
+        <p:spPr>
+          <a:xfrm>
+            <a:off x="0" y="0"/>
+            <a:ext cx="12192002" cy="6858000"/>
+          </a:xfrm>
+          <a:prstGeom prst="rect">
+            <a:avLst/>
+          </a:prstGeom>
+          <a:ln>
+            <a:noFill/>
+          </a:ln>
+        </p:spPr>
+        <p:style>
+          <a:lnRef idx="2">
+            <a:schemeClr val="accent1">
+              <a:shade val="50000"/>
+            </a:schemeClr>
+          </a:lnRef>
+          <a:fillRef idx="1">
+            <a:schemeClr val="accent1"/>
+          </a:fillRef>
+          <a:effectRef idx="0">
+            <a:schemeClr val="accent1"/>
+          </a:effectRef>
+          <a:fontRef idx="minor">
+            <a:schemeClr val="lt1"/>
+          </a:fontRef>
+        </p:style>
+        <p:txBody>
+          <a:bodyPr rtlCol="0" anchor="ctr"/>
+          <a:lstStyle/>
+          <a:p>
+            <a:pPr algn="ctr"/>
+            <a:endParaRPr lang="en-US"/>
+          </a:p>
+        </p:txBody>
+      </p:sp>
+      <p:sp useBgFill="1">
+        <p:nvSpPr>
+          <p:cNvPr id="10" name="Freeform: Shape 9">
+            <a:extLst>
+              <a:ext uri="{FF2B5EF4-FFF2-40B4-BE49-F238E27FC236}">
+                <a16:creationId xmlns:a16="http://schemas.microsoft.com/office/drawing/2014/main" id="{B4E76E7E-94D2-3C57-5163-BF7FE5A40C1F}"/>
+              </a:ext>
+              <a:ext uri="{C183D7F6-B498-43B3-948B-1728B52AA6E4}">
+                <adec:decorative xmlns:adec="http://schemas.microsoft.com/office/drawing/2017/decorative" val="1"/>
+              </a:ext>
+            </a:extLst>
+          </p:cNvPr>
+          <p:cNvSpPr>
+            <a:spLocks noGrp="1" noRot="1" noChangeAspect="1" noMove="1" noResize="1" noEditPoints="1" noAdjustHandles="1" noChangeArrowheads="1" noChangeShapeType="1" noTextEdit="1"/>
+          </p:cNvSpPr>
+          <p:nvPr>
+            <p:extLst>
+              <p:ext uri="{386F3935-93C4-4BCD-93E2-E3B085C9AB24}">
+                <p16:designElem xmlns:p16="http://schemas.microsoft.com/office/powerpoint/2015/main" val="1"/>
+              </p:ext>
+            </p:extLst>
+          </p:nvPr>
+        </p:nvSpPr>
+        <p:spPr>
+          <a:xfrm>
+            <a:off x="-1" y="0"/>
+            <a:ext cx="4818889" cy="6858000"/>
+          </a:xfrm>
+          <a:custGeom>
+            <a:avLst/>
+            <a:gdLst>
+              <a:gd name="connsiteX0" fmla="*/ 0 w 4818889"/>
+              <a:gd name="connsiteY0" fmla="*/ 0 h 6858000"/>
+              <a:gd name="connsiteX1" fmla="*/ 3605911 w 4818889"/>
+              <a:gd name="connsiteY1" fmla="*/ 0 h 6858000"/>
+              <a:gd name="connsiteX2" fmla="*/ 3668894 w 4818889"/>
+              <a:gd name="connsiteY2" fmla="*/ 69271 h 6858000"/>
+              <a:gd name="connsiteX3" fmla="*/ 4818889 w 4818889"/>
+              <a:gd name="connsiteY3" fmla="*/ 3429000 h 6858000"/>
+              <a:gd name="connsiteX4" fmla="*/ 3668894 w 4818889"/>
+              <a:gd name="connsiteY4" fmla="*/ 6788730 h 6858000"/>
+              <a:gd name="connsiteX5" fmla="*/ 3605911 w 4818889"/>
+              <a:gd name="connsiteY5" fmla="*/ 6858000 h 6858000"/>
+              <a:gd name="connsiteX6" fmla="*/ 0 w 4818889"/>
+              <a:gd name="connsiteY6" fmla="*/ 6858000 h 6858000"/>
+            </a:gdLst>
+            <a:ahLst/>
+            <a:cxnLst>
+              <a:cxn ang="0">
+                <a:pos x="connsiteX0" y="connsiteY0"/>
+              </a:cxn>
+              <a:cxn ang="0">
+                <a:pos x="connsiteX1" y="connsiteY1"/>
+              </a:cxn>
+              <a:cxn ang="0">
+                <a:pos x="connsiteX2" y="connsiteY2"/>
+              </a:cxn>
+              <a:cxn ang="0">
+                <a:pos x="connsiteX3" y="connsiteY3"/>
+              </a:cxn>
+              <a:cxn ang="0">
+                <a:pos x="connsiteX4" y="connsiteY4"/>
+              </a:cxn>
+              <a:cxn ang="0">
+                <a:pos x="connsiteX5" y="connsiteY5"/>
+              </a:cxn>
+              <a:cxn ang="0">
+                <a:pos x="connsiteX6" y="connsiteY6"/>
+              </a:cxn>
+            </a:cxnLst>
+            <a:rect l="l" t="t" r="r" b="b"/>
+            <a:pathLst>
+              <a:path w="4818889" h="6858000">
+                <a:moveTo>
+                  <a:pt x="0" y="0"/>
+                </a:moveTo>
+                <a:lnTo>
+                  <a:pt x="3605911" y="0"/>
+                </a:lnTo>
+                <a:lnTo>
+                  <a:pt x="3668894" y="69271"/>
+                </a:lnTo>
+                <a:cubicBezTo>
+                  <a:pt x="4379420" y="929100"/>
+                  <a:pt x="4818889" y="2116944"/>
+                  <a:pt x="4818889" y="3429000"/>
+                </a:cubicBezTo>
+                <a:cubicBezTo>
+                  <a:pt x="4818889" y="4741056"/>
+                  <a:pt x="4379420" y="5928900"/>
+                  <a:pt x="3668894" y="6788730"/>
+                </a:cubicBezTo>
+                <a:lnTo>
+                  <a:pt x="3605911" y="6858000"/>
+                </a:lnTo>
+                <a:lnTo>
+                  <a:pt x="0" y="6858000"/>
+                </a:lnTo>
+                <a:close/>
+              </a:path>
+            </a:pathLst>
+          </a:custGeom>
+          <a:ln w="9525">
+            <a:solidFill>
+              <a:schemeClr val="tx2">
+                <a:lumMod val="10000"/>
+                <a:lumOff val="90000"/>
+              </a:schemeClr>
+            </a:solidFill>
+          </a:ln>
+          <a:effectLst>
+            <a:outerShdw blurRad="50800" dist="38100" algn="l" rotWithShape="0">
+              <a:schemeClr val="bg1">
+                <a:lumMod val="85000"/>
+                <a:alpha val="30000"/>
+              </a:schemeClr>
+            </a:outerShdw>
+          </a:effectLst>
+        </p:spPr>
+        <p:style>
+          <a:lnRef idx="2">
+            <a:schemeClr val="accent1">
+              <a:shade val="50000"/>
+            </a:schemeClr>
+          </a:lnRef>
+          <a:fillRef idx="1">
+            <a:schemeClr val="accent1"/>
+          </a:fillRef>
+          <a:effectRef idx="0">
+            <a:schemeClr val="accent1"/>
+          </a:effectRef>
+          <a:fontRef idx="minor">
+            <a:schemeClr val="lt1"/>
+          </a:fontRef>
+        </p:style>
+        <p:txBody>
+          <a:bodyPr wrap="square" rtlCol="0" anchor="ctr">
+            <a:noAutofit/>
+          </a:bodyPr>
+          <a:lstStyle/>
+          <a:p>
+            <a:pPr marL="0" marR="0" lvl="0" indent="0" algn="ctr" defTabSz="914400" rtl="0" eaLnBrk="1" fontAlgn="auto" latinLnBrk="0" hangingPunct="1">
+              <a:lnSpc>
+                <a:spcPct val="100000"/>
+              </a:lnSpc>
+              <a:spcBef>
+                <a:spcPts val="0"/>
+              </a:spcBef>
+              <a:spcAft>
+                <a:spcPts val="0"/>
+              </a:spcAft>
+              <a:buClrTx/>
+              <a:buSzTx/>
+              <a:buFontTx/>
+              <a:buNone/>
+              <a:tabLst/>
+              <a:defRPr/>
+            </a:pPr>
+            <a:endParaRPr kumimoji="0" lang="en-US" sz="1800" b="0" i="0" u="none" strike="noStrike" kern="1200" cap="none" spc="0" normalizeH="0" baseline="0" noProof="0">
+              <a:ln>
+                <a:noFill/>
+              </a:ln>
+              <a:solidFill>
+                <a:prstClr val="white"/>
+              </a:solidFill>
+              <a:effectLst/>
+              <a:uLnTx/>
+              <a:uFillTx/>
+              <a:latin typeface="Calibri" panose="020F0502020204030204"/>
+              <a:ea typeface="+mn-ea"/>
+              <a:cs typeface="+mn-cs"/>
+            </a:endParaRPr>
+          </a:p>
+        </p:txBody>
+      </p:sp>
+      <p:sp useBgFill="1">
+        <p:nvSpPr>
+          <p:cNvPr id="12" name="Freeform: Shape 11">
+            <a:extLst>
+              <a:ext uri="{FF2B5EF4-FFF2-40B4-BE49-F238E27FC236}">
+                <a16:creationId xmlns:a16="http://schemas.microsoft.com/office/drawing/2014/main" id="{2D8B66D4-3101-5B1F-C68F-79F98C7E75BB}"/>
+              </a:ext>
+              <a:ext uri="{C183D7F6-B498-43B3-948B-1728B52AA6E4}">
+                <adec:decorative xmlns:adec="http://schemas.microsoft.com/office/drawing/2017/decorative" val="1"/>
+              </a:ext>
+            </a:extLst>
+          </p:cNvPr>
+          <p:cNvSpPr>
+            <a:spLocks noGrp="1" noRot="1" noChangeAspect="1" noMove="1" noResize="1" noEditPoints="1" noAdjustHandles="1" noChangeArrowheads="1" noChangeShapeType="1" noTextEdit="1"/>
+          </p:cNvSpPr>
+          <p:nvPr>
+            <p:extLst>
+              <p:ext uri="{386F3935-93C4-4BCD-93E2-E3B085C9AB24}">
+                <p16:designElem xmlns:p16="http://schemas.microsoft.com/office/powerpoint/2015/main" val="1"/>
+              </p:ext>
+            </p:extLst>
+          </p:nvPr>
+        </p:nvSpPr>
+        <p:spPr>
+          <a:xfrm>
+            <a:off x="1" y="0"/>
+            <a:ext cx="4811477" cy="6858000"/>
+          </a:xfrm>
+          <a:custGeom>
+            <a:avLst/>
+            <a:gdLst>
+              <a:gd name="connsiteX0" fmla="*/ 0 w 4811477"/>
+              <a:gd name="connsiteY0" fmla="*/ 0 h 6858000"/>
+              <a:gd name="connsiteX1" fmla="*/ 3598499 w 4811477"/>
+              <a:gd name="connsiteY1" fmla="*/ 0 h 6858000"/>
+              <a:gd name="connsiteX2" fmla="*/ 3661482 w 4811477"/>
+              <a:gd name="connsiteY2" fmla="*/ 69271 h 6858000"/>
+              <a:gd name="connsiteX3" fmla="*/ 4811477 w 4811477"/>
+              <a:gd name="connsiteY3" fmla="*/ 3429000 h 6858000"/>
+              <a:gd name="connsiteX4" fmla="*/ 3661482 w 4811477"/>
+              <a:gd name="connsiteY4" fmla="*/ 6788730 h 6858000"/>
+              <a:gd name="connsiteX5" fmla="*/ 3598499 w 4811477"/>
+              <a:gd name="connsiteY5" fmla="*/ 6858000 h 6858000"/>
+              <a:gd name="connsiteX6" fmla="*/ 0 w 4811477"/>
+              <a:gd name="connsiteY6" fmla="*/ 6858000 h 6858000"/>
+            </a:gdLst>
+            <a:ahLst/>
+            <a:cxnLst>
+              <a:cxn ang="0">
+                <a:pos x="connsiteX0" y="connsiteY0"/>
+              </a:cxn>
+              <a:cxn ang="0">
+                <a:pos x="connsiteX1" y="connsiteY1"/>
+              </a:cxn>
+              <a:cxn ang="0">
+                <a:pos x="connsiteX2" y="connsiteY2"/>
+              </a:cxn>
+              <a:cxn ang="0">
+                <a:pos x="connsiteX3" y="connsiteY3"/>
+              </a:cxn>
+              <a:cxn ang="0">
+                <a:pos x="connsiteX4" y="connsiteY4"/>
+              </a:cxn>
+              <a:cxn ang="0">
+                <a:pos x="connsiteX5" y="connsiteY5"/>
+              </a:cxn>
+              <a:cxn ang="0">
+                <a:pos x="connsiteX6" y="connsiteY6"/>
+              </a:cxn>
+            </a:cxnLst>
+            <a:rect l="l" t="t" r="r" b="b"/>
+            <a:pathLst>
+              <a:path w="4811477" h="6858000">
+                <a:moveTo>
+                  <a:pt x="0" y="0"/>
+                </a:moveTo>
+                <a:lnTo>
+                  <a:pt x="3598499" y="0"/>
+                </a:lnTo>
+                <a:lnTo>
+                  <a:pt x="3661482" y="69271"/>
+                </a:lnTo>
+                <a:cubicBezTo>
+                  <a:pt x="4372008" y="929100"/>
+                  <a:pt x="4811477" y="2116944"/>
+                  <a:pt x="4811477" y="3429000"/>
+                </a:cubicBezTo>
+                <a:cubicBezTo>
+                  <a:pt x="4811477" y="4741056"/>
+                  <a:pt x="4372008" y="5928900"/>
+                  <a:pt x="3661482" y="6788730"/>
+                </a:cubicBezTo>
+                <a:lnTo>
+                  <a:pt x="3598499" y="6858000"/>
+                </a:lnTo>
+                <a:lnTo>
+                  <a:pt x="0" y="6858000"/>
+                </a:lnTo>
+                <a:close/>
+              </a:path>
+            </a:pathLst>
+          </a:custGeom>
+          <a:ln w="9525">
+            <a:noFill/>
+          </a:ln>
+          <a:effectLst/>
+        </p:spPr>
+        <p:style>
+          <a:lnRef idx="2">
+            <a:schemeClr val="accent1">
+              <a:shade val="50000"/>
+            </a:schemeClr>
+          </a:lnRef>
+          <a:fillRef idx="1">
+            <a:schemeClr val="accent1"/>
+          </a:fillRef>
+          <a:effectRef idx="0">
+            <a:schemeClr val="accent1"/>
+          </a:effectRef>
+          <a:fontRef idx="minor">
+            <a:schemeClr val="lt1"/>
+          </a:fontRef>
+        </p:style>
+        <p:txBody>
+          <a:bodyPr wrap="square" rtlCol="0" anchor="ctr">
+            <a:noAutofit/>
+          </a:bodyPr>
+          <a:lstStyle/>
+          <a:p>
+            <a:pPr marL="0" marR="0" lvl="0" indent="0" algn="ctr" defTabSz="914400" rtl="0" eaLnBrk="1" fontAlgn="auto" latinLnBrk="0" hangingPunct="1">
+              <a:lnSpc>
+                <a:spcPct val="100000"/>
+              </a:lnSpc>
+              <a:spcBef>
+                <a:spcPts val="0"/>
+              </a:spcBef>
+              <a:spcAft>
+                <a:spcPts val="0"/>
+              </a:spcAft>
+              <a:buClrTx/>
+              <a:buSzTx/>
+              <a:buFontTx/>
+              <a:buNone/>
+              <a:tabLst/>
+              <a:defRPr/>
+            </a:pPr>
+            <a:endParaRPr kumimoji="0" lang="en-US" sz="1800" b="0" i="0" u="none" strike="noStrike" kern="1200" cap="none" spc="0" normalizeH="0" baseline="0" noProof="0">
+              <a:ln>
+                <a:noFill/>
+              </a:ln>
+              <a:solidFill>
+                <a:prstClr val="white"/>
+              </a:solidFill>
+              <a:effectLst/>
+              <a:uLnTx/>
+              <a:uFillTx/>
+              <a:latin typeface="Calibri" panose="020F0502020204030204"/>
+              <a:ea typeface="+mn-ea"/>
+              <a:cs typeface="+mn-cs"/>
+            </a:endParaRPr>
+          </a:p>
+        </p:txBody>
+      </p:sp>
+      <p:sp>
+        <p:nvSpPr>
+          <p:cNvPr id="2" name="Title 1">
+            <a:extLst>
+              <a:ext uri="{FF2B5EF4-FFF2-40B4-BE49-F238E27FC236}">
+                <a16:creationId xmlns:a16="http://schemas.microsoft.com/office/drawing/2014/main" id="{BBEE26A7-C0D7-FB88-7334-735BA7067610}"/>
+              </a:ext>
+            </a:extLst>
+          </p:cNvPr>
+          <p:cNvSpPr>
+            <a:spLocks noGrp="1"/>
+          </p:cNvSpPr>
+          <p:nvPr>
+            <p:ph type="title"/>
+          </p:nvPr>
+        </p:nvSpPr>
+        <p:spPr>
+          <a:xfrm>
+            <a:off x="621792" y="1161288"/>
+            <a:ext cx="3602736" cy="4526280"/>
+          </a:xfrm>
+        </p:spPr>
+        <p:txBody>
+          <a:bodyPr>
+            <a:normAutofit/>
+          </a:bodyPr>
+          <a:lstStyle/>
+          <a:p>
+            <a:r>
+              <a:rPr lang="en-US" dirty="0"/>
+              <a:t>Tech Stack</a:t>
+            </a:r>
+            <a:br>
+              <a:rPr lang="en-US" dirty="0"/>
+            </a:br>
+            <a:r>
+              <a:rPr lang="en-US" dirty="0"/>
+              <a:t>Backend</a:t>
+            </a:r>
+          </a:p>
+        </p:txBody>
+      </p:sp>
+      <p:sp>
+        <p:nvSpPr>
+          <p:cNvPr id="14" name="Rectangle 13">
+            <a:extLst>
+              <a:ext uri="{FF2B5EF4-FFF2-40B4-BE49-F238E27FC236}">
+                <a16:creationId xmlns:a16="http://schemas.microsoft.com/office/drawing/2014/main" id="{ACDEC5F4-BF85-6050-7E02-5C8CE6C007E3}"/>
+              </a:ext>
+              <a:ext uri="{C183D7F6-B498-43B3-948B-1728B52AA6E4}">
+                <adec:decorative xmlns:adec="http://schemas.microsoft.com/office/drawing/2017/decorative" val="1"/>
+              </a:ext>
+            </a:extLst>
+          </p:cNvPr>
+          <p:cNvSpPr>
+            <a:spLocks noGrp="1" noRot="1" noChangeAspect="1" noMove="1" noResize="1" noEditPoints="1" noAdjustHandles="1" noChangeArrowheads="1" noChangeShapeType="1" noTextEdit="1"/>
+          </p:cNvSpPr>
+          <p:nvPr>
+            <p:extLst>
+              <p:ext uri="{386F3935-93C4-4BCD-93E2-E3B085C9AB24}">
+                <p16:designElem xmlns:p16="http://schemas.microsoft.com/office/powerpoint/2015/main" val="1"/>
+              </p:ext>
+            </p:extLst>
+          </p:nvPr>
+        </p:nvSpPr>
+        <p:spPr>
+          <a:xfrm>
+            <a:off x="0" y="3102049"/>
+            <a:ext cx="128016" cy="653903"/>
+          </a:xfrm>
+          <a:prstGeom prst="rect">
+            <a:avLst/>
+          </a:prstGeom>
+          <a:solidFill>
+            <a:schemeClr val="accent1"/>
+          </a:solidFill>
+          <a:ln>
+            <a:noFill/>
+          </a:ln>
+        </p:spPr>
+        <p:style>
+          <a:lnRef idx="2">
+            <a:schemeClr val="accent1">
+              <a:shade val="50000"/>
+            </a:schemeClr>
+          </a:lnRef>
+          <a:fillRef idx="1">
+            <a:schemeClr val="accent1"/>
+          </a:fillRef>
+          <a:effectRef idx="0">
+            <a:schemeClr val="accent1"/>
+          </a:effectRef>
+          <a:fontRef idx="minor">
+            <a:schemeClr val="lt1"/>
+          </a:fontRef>
+        </p:style>
+        <p:txBody>
+          <a:bodyPr rtlCol="0" anchor="ctr"/>
+          <a:lstStyle/>
+          <a:p>
+            <a:pPr marL="0" marR="0" lvl="0" indent="0" algn="ctr" defTabSz="914400" rtl="0" eaLnBrk="1" fontAlgn="auto" latinLnBrk="0" hangingPunct="1">
+              <a:lnSpc>
+                <a:spcPct val="100000"/>
+              </a:lnSpc>
+              <a:spcBef>
+                <a:spcPts val="0"/>
+              </a:spcBef>
+              <a:spcAft>
+                <a:spcPts val="0"/>
+              </a:spcAft>
+              <a:buClrTx/>
+              <a:buSzTx/>
+              <a:buFontTx/>
+              <a:buNone/>
+              <a:tabLst/>
+              <a:defRPr/>
+            </a:pPr>
+            <a:endParaRPr kumimoji="0" lang="en-US" sz="1800" b="0" i="0" u="none" strike="noStrike" kern="1200" cap="none" spc="0" normalizeH="0" baseline="0" noProof="0">
+              <a:ln>
+                <a:noFill/>
+              </a:ln>
+              <a:solidFill>
+                <a:prstClr val="white"/>
+              </a:solidFill>
+              <a:effectLst/>
+              <a:uLnTx/>
+              <a:uFillTx/>
+              <a:latin typeface="Calibri" panose="020F0502020204030204"/>
+              <a:ea typeface="+mn-ea"/>
+              <a:cs typeface="+mn-cs"/>
+            </a:endParaRPr>
+          </a:p>
+        </p:txBody>
+      </p:sp>
+      <p:sp>
+        <p:nvSpPr>
+          <p:cNvPr id="3" name="Content Placeholder 2">
+            <a:extLst>
+              <a:ext uri="{FF2B5EF4-FFF2-40B4-BE49-F238E27FC236}">
+                <a16:creationId xmlns:a16="http://schemas.microsoft.com/office/drawing/2014/main" id="{19D5A7A0-9C0D-F227-6D22-CED680F6DA89}"/>
+              </a:ext>
+            </a:extLst>
+          </p:cNvPr>
+          <p:cNvSpPr>
+            <a:spLocks noGrp="1"/>
+          </p:cNvSpPr>
+          <p:nvPr>
+            <p:ph idx="1"/>
+          </p:nvPr>
+        </p:nvSpPr>
+        <p:spPr>
+          <a:xfrm>
+            <a:off x="5434149" y="932688"/>
+            <a:ext cx="5916603" cy="4992624"/>
+          </a:xfrm>
+        </p:spPr>
+        <p:txBody>
+          <a:bodyPr anchor="ctr">
+            <a:normAutofit/>
+          </a:bodyPr>
+          <a:lstStyle/>
+          <a:p>
+            <a:r>
+              <a:rPr lang="en-US" sz="1900" dirty="0"/>
+              <a:t>Back End:</a:t>
+            </a:r>
+          </a:p>
+          <a:p>
+            <a:pPr lvl="1"/>
+            <a:r>
+              <a:rPr lang="en-US" sz="1900" dirty="0"/>
+              <a:t>NextJS (Api Routes)</a:t>
+            </a:r>
+          </a:p>
+          <a:p>
+            <a:pPr lvl="1"/>
+            <a:r>
+              <a:rPr lang="en-US" sz="1900" dirty="0"/>
+              <a:t>AWS S3 Buckets (file storage e.g. pictures, exported CVs)</a:t>
+            </a:r>
+          </a:p>
+          <a:p>
+            <a:pPr lvl="1"/>
+            <a:r>
+              <a:rPr lang="en-US" sz="1900" dirty="0"/>
+              <a:t>AWS DynamoDB (NoSQL database)</a:t>
+            </a:r>
+          </a:p>
+          <a:p>
+            <a:pPr lvl="1"/>
+            <a:r>
+              <a:rPr lang="en-US" sz="1900" dirty="0"/>
+              <a:t>AWS Cognito (User management and authentication.</a:t>
+            </a:r>
+          </a:p>
+        </p:txBody>
+      </p:sp>
+    </p:spTree>
+    <p:extLst>
+      <p:ext uri="{BB962C8B-B14F-4D97-AF65-F5344CB8AC3E}">
+        <p14:creationId xmlns:p14="http://schemas.microsoft.com/office/powerpoint/2010/main" val="3366428917"/>
+      </p:ext>
+    </p:extLst>
+  </p:cSld>
+  <p:clrMapOvr>
+    <a:masterClrMapping/>
+  </p:clrMapOvr>
+</p:sld>
+</file>
+
+<file path=ppt/slides/slide5.xml><?xml version="1.0" encoding="utf-8"?>
 <p:sld xmlns:a="http://schemas.openxmlformats.org/drawingml/2006/main" xmlns:r="http://schemas.openxmlformats.org/officeDocument/2006/relationships" xmlns:p="http://schemas.openxmlformats.org/presentationml/2006/main">
   <p:cSld>
     <p:bg>
@@ -11499,10 +12111,10 @@
       </p:sp>
       <p:pic>
         <p:nvPicPr>
-          <p:cNvPr id="5" name="Picture 4" descr="A screenshot of a computer&#10;&#10;AI-generated content may be incorrect.">
-            <a:extLst>
-              <a:ext uri="{FF2B5EF4-FFF2-40B4-BE49-F238E27FC236}">
-                <a16:creationId xmlns:a16="http://schemas.microsoft.com/office/drawing/2014/main" id="{9BD6BBB6-13ED-CCC5-6D30-A568FC15C9F2}"/>
+          <p:cNvPr id="8" name="Picture 7" descr="A screenshot of a login page&#10;&#10;AI-generated content may be incorrect.">
+            <a:extLst>
+              <a:ext uri="{FF2B5EF4-FFF2-40B4-BE49-F238E27FC236}">
+                <a16:creationId xmlns:a16="http://schemas.microsoft.com/office/drawing/2014/main" id="{3556042F-7362-0347-7411-CA9789DFC4C5}"/>
               </a:ext>
             </a:extLst>
           </p:cNvPr>
@@ -11513,36 +12125,6 @@
         </p:nvPicPr>
         <p:blipFill>
           <a:blip r:embed="rId2"/>
-          <a:stretch>
-            <a:fillRect/>
-          </a:stretch>
-        </p:blipFill>
-        <p:spPr>
-          <a:xfrm>
-            <a:off x="473583" y="2171760"/>
-            <a:ext cx="6463647" cy="3889143"/>
-          </a:xfrm>
-          <a:prstGeom prst="rect">
-            <a:avLst/>
-          </a:prstGeom>
-        </p:spPr>
-      </p:pic>
-      <p:pic>
-        <p:nvPicPr>
-          <p:cNvPr id="8" name="Picture 7" descr="A screenshot of a login page&#10;&#10;AI-generated content may be incorrect.">
-            <a:extLst>
-              <a:ext uri="{FF2B5EF4-FFF2-40B4-BE49-F238E27FC236}">
-                <a16:creationId xmlns:a16="http://schemas.microsoft.com/office/drawing/2014/main" id="{3556042F-7362-0347-7411-CA9789DFC4C5}"/>
-              </a:ext>
-            </a:extLst>
-          </p:cNvPr>
-          <p:cNvPicPr>
-            <a:picLocks noChangeAspect="1"/>
-          </p:cNvPicPr>
-          <p:nvPr/>
-        </p:nvPicPr>
-        <p:blipFill>
-          <a:blip r:embed="rId3"/>
           <a:stretch>
             <a:fillRect/>
           </a:stretch>
@@ -11557,742 +12139,12 @@
           </a:prstGeom>
         </p:spPr>
       </p:pic>
-    </p:spTree>
-    <p:extLst>
-      <p:ext uri="{BB962C8B-B14F-4D97-AF65-F5344CB8AC3E}">
-        <p14:creationId xmlns:p14="http://schemas.microsoft.com/office/powerpoint/2010/main" val="3687148187"/>
-      </p:ext>
-    </p:extLst>
-  </p:cSld>
-  <p:clrMapOvr>
-    <a:masterClrMapping/>
-  </p:clrMapOvr>
-</p:sld>
-</file>
-
-<file path=ppt/slides/slide5.xml><?xml version="1.0" encoding="utf-8"?>
-<p:sld xmlns:a="http://schemas.openxmlformats.org/drawingml/2006/main" xmlns:r="http://schemas.openxmlformats.org/officeDocument/2006/relationships" xmlns:p="http://schemas.openxmlformats.org/presentationml/2006/main">
-  <p:cSld>
-    <p:bg>
-      <p:bgPr>
-        <a:solidFill>
-          <a:schemeClr val="bg1"/>
-        </a:solidFill>
-        <a:effectLst/>
-      </p:bgPr>
-    </p:bg>
-    <p:spTree>
-      <p:nvGrpSpPr>
-        <p:cNvPr id="1" name=""/>
-        <p:cNvGrpSpPr/>
-        <p:nvPr/>
-      </p:nvGrpSpPr>
-      <p:grpSpPr>
-        <a:xfrm>
-          <a:off x="0" y="0"/>
-          <a:ext cx="0" cy="0"/>
-          <a:chOff x="0" y="0"/>
-          <a:chExt cx="0" cy="0"/>
-        </a:xfrm>
-      </p:grpSpPr>
-      <p:sp useBgFill="1">
-        <p:nvSpPr>
-          <p:cNvPr id="10" name="Rectangle 9">
-            <a:extLst>
-              <a:ext uri="{FF2B5EF4-FFF2-40B4-BE49-F238E27FC236}">
-                <a16:creationId xmlns:a16="http://schemas.microsoft.com/office/drawing/2014/main" id="{0288C6B4-AFC3-407F-A595-EFFD38D4CCAF}"/>
-              </a:ext>
-              <a:ext uri="{C183D7F6-B498-43B3-948B-1728B52AA6E4}">
-                <adec:decorative xmlns:adec="http://schemas.microsoft.com/office/drawing/2017/decorative" val="1"/>
-              </a:ext>
-            </a:extLst>
-          </p:cNvPr>
-          <p:cNvSpPr>
-            <a:spLocks noGrp="1" noRot="1" noChangeAspect="1" noMove="1" noResize="1" noEditPoints="1" noAdjustHandles="1" noChangeArrowheads="1" noChangeShapeType="1" noTextEdit="1"/>
-          </p:cNvSpPr>
-          <p:nvPr>
-            <p:extLst>
-              <p:ext uri="{386F3935-93C4-4BCD-93E2-E3B085C9AB24}">
-                <p16:designElem xmlns:p16="http://schemas.microsoft.com/office/powerpoint/2015/main" val="1"/>
-              </p:ext>
-            </p:extLst>
-          </p:nvPr>
-        </p:nvSpPr>
-        <p:spPr>
-          <a:xfrm>
-            <a:off x="0" y="0"/>
-            <a:ext cx="12192000" cy="6858000"/>
-          </a:xfrm>
-          <a:prstGeom prst="rect">
-            <a:avLst/>
-          </a:prstGeom>
-          <a:ln>
-            <a:noFill/>
-          </a:ln>
-        </p:spPr>
-        <p:style>
-          <a:lnRef idx="2">
-            <a:schemeClr val="accent1">
-              <a:shade val="50000"/>
-            </a:schemeClr>
-          </a:lnRef>
-          <a:fillRef idx="1">
-            <a:schemeClr val="accent1"/>
-          </a:fillRef>
-          <a:effectRef idx="0">
-            <a:schemeClr val="accent1"/>
-          </a:effectRef>
-          <a:fontRef idx="minor">
-            <a:schemeClr val="lt1"/>
-          </a:fontRef>
-        </p:style>
-        <p:txBody>
-          <a:bodyPr rtlCol="0" anchor="ctr"/>
-          <a:lstStyle/>
-          <a:p>
-            <a:pPr algn="ctr"/>
-            <a:endParaRPr lang="en-US"/>
-          </a:p>
-        </p:txBody>
-      </p:sp>
-      <p:sp useBgFill="1">
-        <p:nvSpPr>
-          <p:cNvPr id="12" name="Freeform: Shape 11">
-            <a:extLst>
-              <a:ext uri="{FF2B5EF4-FFF2-40B4-BE49-F238E27FC236}">
-                <a16:creationId xmlns:a16="http://schemas.microsoft.com/office/drawing/2014/main" id="{CF236821-17FE-429B-8D2C-08E13A64EA40}"/>
-              </a:ext>
-              <a:ext uri="{C183D7F6-B498-43B3-948B-1728B52AA6E4}">
-                <adec:decorative xmlns:adec="http://schemas.microsoft.com/office/drawing/2017/decorative" val="1"/>
-              </a:ext>
-            </a:extLst>
-          </p:cNvPr>
-          <p:cNvSpPr>
-            <a:spLocks noGrp="1" noRot="1" noChangeAspect="1" noMove="1" noResize="1" noEditPoints="1" noAdjustHandles="1" noChangeArrowheads="1" noChangeShapeType="1" noTextEdit="1"/>
-          </p:cNvSpPr>
-          <p:nvPr>
-            <p:extLst>
-              <p:ext uri="{386F3935-93C4-4BCD-93E2-E3B085C9AB24}">
-                <p16:designElem xmlns:p16="http://schemas.microsoft.com/office/powerpoint/2015/main" val="1"/>
-              </p:ext>
-            </p:extLst>
-          </p:nvPr>
-        </p:nvSpPr>
-        <p:spPr>
-          <a:xfrm>
-            <a:off x="-1" y="0"/>
-            <a:ext cx="4455673" cy="6858000"/>
-          </a:xfrm>
-          <a:custGeom>
-            <a:avLst/>
-            <a:gdLst>
-              <a:gd name="connsiteX0" fmla="*/ 0 w 4455673"/>
-              <a:gd name="connsiteY0" fmla="*/ 0 h 6858000"/>
-              <a:gd name="connsiteX1" fmla="*/ 3242695 w 4455673"/>
-              <a:gd name="connsiteY1" fmla="*/ 0 h 6858000"/>
-              <a:gd name="connsiteX2" fmla="*/ 3305678 w 4455673"/>
-              <a:gd name="connsiteY2" fmla="*/ 69271 h 6858000"/>
-              <a:gd name="connsiteX3" fmla="*/ 4455673 w 4455673"/>
-              <a:gd name="connsiteY3" fmla="*/ 3429000 h 6858000"/>
-              <a:gd name="connsiteX4" fmla="*/ 3305678 w 4455673"/>
-              <a:gd name="connsiteY4" fmla="*/ 6788730 h 6858000"/>
-              <a:gd name="connsiteX5" fmla="*/ 3242695 w 4455673"/>
-              <a:gd name="connsiteY5" fmla="*/ 6858000 h 6858000"/>
-              <a:gd name="connsiteX6" fmla="*/ 0 w 4455673"/>
-              <a:gd name="connsiteY6" fmla="*/ 6858000 h 6858000"/>
-            </a:gdLst>
-            <a:ahLst/>
-            <a:cxnLst>
-              <a:cxn ang="0">
-                <a:pos x="connsiteX0" y="connsiteY0"/>
-              </a:cxn>
-              <a:cxn ang="0">
-                <a:pos x="connsiteX1" y="connsiteY1"/>
-              </a:cxn>
-              <a:cxn ang="0">
-                <a:pos x="connsiteX2" y="connsiteY2"/>
-              </a:cxn>
-              <a:cxn ang="0">
-                <a:pos x="connsiteX3" y="connsiteY3"/>
-              </a:cxn>
-              <a:cxn ang="0">
-                <a:pos x="connsiteX4" y="connsiteY4"/>
-              </a:cxn>
-              <a:cxn ang="0">
-                <a:pos x="connsiteX5" y="connsiteY5"/>
-              </a:cxn>
-              <a:cxn ang="0">
-                <a:pos x="connsiteX6" y="connsiteY6"/>
-              </a:cxn>
-            </a:cxnLst>
-            <a:rect l="l" t="t" r="r" b="b"/>
-            <a:pathLst>
-              <a:path w="4455673" h="6858000">
-                <a:moveTo>
-                  <a:pt x="0" y="0"/>
-                </a:moveTo>
-                <a:lnTo>
-                  <a:pt x="3242695" y="0"/>
-                </a:lnTo>
-                <a:lnTo>
-                  <a:pt x="3305678" y="69271"/>
-                </a:lnTo>
-                <a:cubicBezTo>
-                  <a:pt x="4016204" y="929100"/>
-                  <a:pt x="4455673" y="2116944"/>
-                  <a:pt x="4455673" y="3429000"/>
-                </a:cubicBezTo>
-                <a:cubicBezTo>
-                  <a:pt x="4455673" y="4741056"/>
-                  <a:pt x="4016204" y="5928900"/>
-                  <a:pt x="3305678" y="6788730"/>
-                </a:cubicBezTo>
-                <a:lnTo>
-                  <a:pt x="3242695" y="6858000"/>
-                </a:lnTo>
-                <a:lnTo>
-                  <a:pt x="0" y="6858000"/>
-                </a:lnTo>
-                <a:close/>
-              </a:path>
-            </a:pathLst>
-          </a:custGeom>
-          <a:ln w="9525">
-            <a:solidFill>
-              <a:schemeClr val="tx2">
-                <a:lumMod val="10000"/>
-                <a:lumOff val="90000"/>
-              </a:schemeClr>
-            </a:solidFill>
-          </a:ln>
-          <a:effectLst>
-            <a:outerShdw blurRad="50800" dist="38100" algn="l" rotWithShape="0">
-              <a:schemeClr val="bg1">
-                <a:lumMod val="85000"/>
-                <a:alpha val="30000"/>
-              </a:schemeClr>
-            </a:outerShdw>
-          </a:effectLst>
-        </p:spPr>
-        <p:style>
-          <a:lnRef idx="2">
-            <a:schemeClr val="accent1">
-              <a:shade val="50000"/>
-            </a:schemeClr>
-          </a:lnRef>
-          <a:fillRef idx="1">
-            <a:schemeClr val="accent1"/>
-          </a:fillRef>
-          <a:effectRef idx="0">
-            <a:schemeClr val="accent1"/>
-          </a:effectRef>
-          <a:fontRef idx="minor">
-            <a:schemeClr val="lt1"/>
-          </a:fontRef>
-        </p:style>
-        <p:txBody>
-          <a:bodyPr wrap="square" rtlCol="0" anchor="ctr">
-            <a:noAutofit/>
-          </a:bodyPr>
-          <a:lstStyle/>
-          <a:p>
-            <a:pPr marL="0" marR="0" lvl="0" indent="0" algn="ctr" defTabSz="914400" rtl="0" eaLnBrk="1" fontAlgn="auto" latinLnBrk="0" hangingPunct="1">
-              <a:lnSpc>
-                <a:spcPct val="100000"/>
-              </a:lnSpc>
-              <a:spcBef>
-                <a:spcPts val="0"/>
-              </a:spcBef>
-              <a:spcAft>
-                <a:spcPts val="0"/>
-              </a:spcAft>
-              <a:buClrTx/>
-              <a:buSzTx/>
-              <a:buFontTx/>
-              <a:buNone/>
-              <a:tabLst/>
-              <a:defRPr/>
-            </a:pPr>
-            <a:endParaRPr kumimoji="0" lang="en-US" sz="1800" b="0" i="0" u="none" strike="noStrike" kern="1200" cap="none" spc="0" normalizeH="0" baseline="0" noProof="0">
-              <a:ln>
-                <a:noFill/>
-              </a:ln>
-              <a:solidFill>
-                <a:prstClr val="white"/>
-              </a:solidFill>
-              <a:effectLst/>
-              <a:uLnTx/>
-              <a:uFillTx/>
-              <a:latin typeface="Calibri" panose="020F0502020204030204"/>
-              <a:ea typeface="+mn-ea"/>
-              <a:cs typeface="+mn-cs"/>
-            </a:endParaRPr>
-          </a:p>
-        </p:txBody>
-      </p:sp>
-      <p:sp useBgFill="1">
-        <p:nvSpPr>
-          <p:cNvPr id="14" name="Freeform: Shape 13">
-            <a:extLst>
-              <a:ext uri="{FF2B5EF4-FFF2-40B4-BE49-F238E27FC236}">
-                <a16:creationId xmlns:a16="http://schemas.microsoft.com/office/drawing/2014/main" id="{C0BDBCD2-E081-43AB-9119-C55465E59757}"/>
-              </a:ext>
-              <a:ext uri="{C183D7F6-B498-43B3-948B-1728B52AA6E4}">
-                <adec:decorative xmlns:adec="http://schemas.microsoft.com/office/drawing/2017/decorative" val="1"/>
-              </a:ext>
-            </a:extLst>
-          </p:cNvPr>
-          <p:cNvSpPr>
-            <a:spLocks noGrp="1" noRot="1" noChangeAspect="1" noMove="1" noResize="1" noEditPoints="1" noAdjustHandles="1" noChangeArrowheads="1" noChangeShapeType="1" noTextEdit="1"/>
-          </p:cNvSpPr>
-          <p:nvPr>
-            <p:extLst>
-              <p:ext uri="{386F3935-93C4-4BCD-93E2-E3B085C9AB24}">
-                <p16:designElem xmlns:p16="http://schemas.microsoft.com/office/powerpoint/2015/main" val="1"/>
-              </p:ext>
-            </p:extLst>
-          </p:nvPr>
-        </p:nvSpPr>
-        <p:spPr>
-          <a:xfrm>
-            <a:off x="0" y="0"/>
-            <a:ext cx="4446529" cy="6858000"/>
-          </a:xfrm>
-          <a:custGeom>
-            <a:avLst/>
-            <a:gdLst>
-              <a:gd name="connsiteX0" fmla="*/ 0 w 4446529"/>
-              <a:gd name="connsiteY0" fmla="*/ 0 h 6858000"/>
-              <a:gd name="connsiteX1" fmla="*/ 3233551 w 4446529"/>
-              <a:gd name="connsiteY1" fmla="*/ 0 h 6858000"/>
-              <a:gd name="connsiteX2" fmla="*/ 3296534 w 4446529"/>
-              <a:gd name="connsiteY2" fmla="*/ 69271 h 6858000"/>
-              <a:gd name="connsiteX3" fmla="*/ 4446529 w 4446529"/>
-              <a:gd name="connsiteY3" fmla="*/ 3429000 h 6858000"/>
-              <a:gd name="connsiteX4" fmla="*/ 3296534 w 4446529"/>
-              <a:gd name="connsiteY4" fmla="*/ 6788730 h 6858000"/>
-              <a:gd name="connsiteX5" fmla="*/ 3233551 w 4446529"/>
-              <a:gd name="connsiteY5" fmla="*/ 6858000 h 6858000"/>
-              <a:gd name="connsiteX6" fmla="*/ 0 w 4446529"/>
-              <a:gd name="connsiteY6" fmla="*/ 6858000 h 6858000"/>
-            </a:gdLst>
-            <a:ahLst/>
-            <a:cxnLst>
-              <a:cxn ang="0">
-                <a:pos x="connsiteX0" y="connsiteY0"/>
-              </a:cxn>
-              <a:cxn ang="0">
-                <a:pos x="connsiteX1" y="connsiteY1"/>
-              </a:cxn>
-              <a:cxn ang="0">
-                <a:pos x="connsiteX2" y="connsiteY2"/>
-              </a:cxn>
-              <a:cxn ang="0">
-                <a:pos x="connsiteX3" y="connsiteY3"/>
-              </a:cxn>
-              <a:cxn ang="0">
-                <a:pos x="connsiteX4" y="connsiteY4"/>
-              </a:cxn>
-              <a:cxn ang="0">
-                <a:pos x="connsiteX5" y="connsiteY5"/>
-              </a:cxn>
-              <a:cxn ang="0">
-                <a:pos x="connsiteX6" y="connsiteY6"/>
-              </a:cxn>
-            </a:cxnLst>
-            <a:rect l="l" t="t" r="r" b="b"/>
-            <a:pathLst>
-              <a:path w="4446529" h="6858000">
-                <a:moveTo>
-                  <a:pt x="0" y="0"/>
-                </a:moveTo>
-                <a:lnTo>
-                  <a:pt x="3233551" y="0"/>
-                </a:lnTo>
-                <a:lnTo>
-                  <a:pt x="3296534" y="69271"/>
-                </a:lnTo>
-                <a:cubicBezTo>
-                  <a:pt x="4007060" y="929100"/>
-                  <a:pt x="4446529" y="2116944"/>
-                  <a:pt x="4446529" y="3429000"/>
-                </a:cubicBezTo>
-                <a:cubicBezTo>
-                  <a:pt x="4446529" y="4741056"/>
-                  <a:pt x="4007060" y="5928900"/>
-                  <a:pt x="3296534" y="6788730"/>
-                </a:cubicBezTo>
-                <a:lnTo>
-                  <a:pt x="3233551" y="6858000"/>
-                </a:lnTo>
-                <a:lnTo>
-                  <a:pt x="0" y="6858000"/>
-                </a:lnTo>
-                <a:close/>
-              </a:path>
-            </a:pathLst>
-          </a:custGeom>
-          <a:ln w="9525">
-            <a:noFill/>
-          </a:ln>
-          <a:effectLst/>
-        </p:spPr>
-        <p:style>
-          <a:lnRef idx="2">
-            <a:schemeClr val="accent1">
-              <a:shade val="50000"/>
-            </a:schemeClr>
-          </a:lnRef>
-          <a:fillRef idx="1">
-            <a:schemeClr val="accent1"/>
-          </a:fillRef>
-          <a:effectRef idx="0">
-            <a:schemeClr val="accent1"/>
-          </a:effectRef>
-          <a:fontRef idx="minor">
-            <a:schemeClr val="lt1"/>
-          </a:fontRef>
-        </p:style>
-        <p:txBody>
-          <a:bodyPr wrap="square" rtlCol="0" anchor="ctr">
-            <a:noAutofit/>
-          </a:bodyPr>
-          <a:lstStyle/>
-          <a:p>
-            <a:pPr marL="0" marR="0" lvl="0" indent="0" algn="ctr" defTabSz="914400" rtl="0" eaLnBrk="1" fontAlgn="auto" latinLnBrk="0" hangingPunct="1">
-              <a:lnSpc>
-                <a:spcPct val="100000"/>
-              </a:lnSpc>
-              <a:spcBef>
-                <a:spcPts val="0"/>
-              </a:spcBef>
-              <a:spcAft>
-                <a:spcPts val="0"/>
-              </a:spcAft>
-              <a:buClrTx/>
-              <a:buSzTx/>
-              <a:buFontTx/>
-              <a:buNone/>
-              <a:tabLst/>
-              <a:defRPr/>
-            </a:pPr>
-            <a:endParaRPr kumimoji="0" lang="en-US" sz="1800" b="0" i="0" u="none" strike="noStrike" kern="1200" cap="none" spc="0" normalizeH="0" baseline="0" noProof="0">
-              <a:ln>
-                <a:noFill/>
-              </a:ln>
-              <a:solidFill>
-                <a:prstClr val="white"/>
-              </a:solidFill>
-              <a:effectLst/>
-              <a:uLnTx/>
-              <a:uFillTx/>
-              <a:latin typeface="Calibri" panose="020F0502020204030204"/>
-              <a:ea typeface="+mn-ea"/>
-              <a:cs typeface="+mn-cs"/>
-            </a:endParaRPr>
-          </a:p>
-        </p:txBody>
-      </p:sp>
-      <p:sp>
-        <p:nvSpPr>
-          <p:cNvPr id="2" name="Title 1">
-            <a:extLst>
-              <a:ext uri="{FF2B5EF4-FFF2-40B4-BE49-F238E27FC236}">
-                <a16:creationId xmlns:a16="http://schemas.microsoft.com/office/drawing/2014/main" id="{3E15C890-08D3-8E45-4BF8-1BA2C5A1A4DA}"/>
-              </a:ext>
-            </a:extLst>
-          </p:cNvPr>
-          <p:cNvSpPr>
-            <a:spLocks noGrp="1"/>
-          </p:cNvSpPr>
-          <p:nvPr>
-            <p:ph type="title"/>
-          </p:nvPr>
-        </p:nvSpPr>
-        <p:spPr>
-          <a:xfrm>
-            <a:off x="371094" y="1161288"/>
-            <a:ext cx="3438144" cy="1239012"/>
-          </a:xfrm>
-        </p:spPr>
-        <p:txBody>
-          <a:bodyPr anchor="ctr">
-            <a:normAutofit/>
-          </a:bodyPr>
-          <a:lstStyle/>
-          <a:p>
-            <a:r>
-              <a:rPr lang="en-US" sz="2600"/>
-              <a:t>Design – Component Library</a:t>
-            </a:r>
-          </a:p>
-        </p:txBody>
-      </p:sp>
-      <p:sp>
-        <p:nvSpPr>
-          <p:cNvPr id="16" name="Rectangle 15">
-            <a:extLst>
-              <a:ext uri="{FF2B5EF4-FFF2-40B4-BE49-F238E27FC236}">
-                <a16:creationId xmlns:a16="http://schemas.microsoft.com/office/drawing/2014/main" id="{98E79BE4-34FE-485A-98A5-92CE8F7C4743}"/>
-              </a:ext>
-              <a:ext uri="{C183D7F6-B498-43B3-948B-1728B52AA6E4}">
-                <adec:decorative xmlns:adec="http://schemas.microsoft.com/office/drawing/2017/decorative" val="1"/>
-              </a:ext>
-            </a:extLst>
-          </p:cNvPr>
-          <p:cNvSpPr>
-            <a:spLocks noGrp="1" noRot="1" noChangeAspect="1" noMove="1" noResize="1" noEditPoints="1" noAdjustHandles="1" noChangeArrowheads="1" noChangeShapeType="1" noTextEdit="1"/>
-          </p:cNvSpPr>
-          <p:nvPr>
-            <p:extLst>
-              <p:ext uri="{386F3935-93C4-4BCD-93E2-E3B085C9AB24}">
-                <p16:designElem xmlns:p16="http://schemas.microsoft.com/office/powerpoint/2015/main" val="1"/>
-              </p:ext>
-            </p:extLst>
-          </p:nvPr>
-        </p:nvSpPr>
-        <p:spPr>
-          <a:xfrm>
-            <a:off x="0" y="1426546"/>
-            <a:ext cx="128016" cy="653903"/>
-          </a:xfrm>
-          <a:prstGeom prst="rect">
-            <a:avLst/>
-          </a:prstGeom>
-          <a:solidFill>
-            <a:schemeClr val="accent1"/>
-          </a:solidFill>
-          <a:ln>
-            <a:noFill/>
-          </a:ln>
-        </p:spPr>
-        <p:style>
-          <a:lnRef idx="2">
-            <a:schemeClr val="accent1">
-              <a:shade val="50000"/>
-            </a:schemeClr>
-          </a:lnRef>
-          <a:fillRef idx="1">
-            <a:schemeClr val="accent1"/>
-          </a:fillRef>
-          <a:effectRef idx="0">
-            <a:schemeClr val="accent1"/>
-          </a:effectRef>
-          <a:fontRef idx="minor">
-            <a:schemeClr val="lt1"/>
-          </a:fontRef>
-        </p:style>
-        <p:txBody>
-          <a:bodyPr rtlCol="0" anchor="ctr"/>
-          <a:lstStyle/>
-          <a:p>
-            <a:pPr marL="0" marR="0" lvl="0" indent="0" algn="ctr" defTabSz="914400" rtl="0" eaLnBrk="1" fontAlgn="auto" latinLnBrk="0" hangingPunct="1">
-              <a:lnSpc>
-                <a:spcPct val="100000"/>
-              </a:lnSpc>
-              <a:spcBef>
-                <a:spcPts val="0"/>
-              </a:spcBef>
-              <a:spcAft>
-                <a:spcPts val="0"/>
-              </a:spcAft>
-              <a:buClrTx/>
-              <a:buSzTx/>
-              <a:buFontTx/>
-              <a:buNone/>
-              <a:tabLst/>
-              <a:defRPr/>
-            </a:pPr>
-            <a:endParaRPr kumimoji="0" lang="en-US" sz="1800" b="0" i="0" u="none" strike="noStrike" kern="1200" cap="none" spc="0" normalizeH="0" baseline="0" noProof="0">
-              <a:ln>
-                <a:noFill/>
-              </a:ln>
-              <a:solidFill>
-                <a:prstClr val="white"/>
-              </a:solidFill>
-              <a:effectLst/>
-              <a:uLnTx/>
-              <a:uFillTx/>
-              <a:latin typeface="Calibri" panose="020F0502020204030204"/>
-              <a:ea typeface="+mn-ea"/>
-              <a:cs typeface="+mn-cs"/>
-            </a:endParaRPr>
-          </a:p>
-        </p:txBody>
-      </p:sp>
-      <p:sp>
-        <p:nvSpPr>
-          <p:cNvPr id="18" name="Rectangle 17">
-            <a:extLst>
-              <a:ext uri="{FF2B5EF4-FFF2-40B4-BE49-F238E27FC236}">
-                <a16:creationId xmlns:a16="http://schemas.microsoft.com/office/drawing/2014/main" id="{7A5F0580-5EE9-419F-96EE-B6529EF6E7D0}"/>
-              </a:ext>
-              <a:ext uri="{C183D7F6-B498-43B3-948B-1728B52AA6E4}">
-                <adec:decorative xmlns:adec="http://schemas.microsoft.com/office/drawing/2017/decorative" val="1"/>
-              </a:ext>
-            </a:extLst>
-          </p:cNvPr>
-          <p:cNvSpPr>
-            <a:spLocks noGrp="1" noRot="1" noChangeAspect="1" noMove="1" noResize="1" noEditPoints="1" noAdjustHandles="1" noChangeArrowheads="1" noChangeShapeType="1" noTextEdit="1"/>
-          </p:cNvSpPr>
-          <p:nvPr>
-            <p:extLst>
-              <p:ext uri="{386F3935-93C4-4BCD-93E2-E3B085C9AB24}">
-                <p16:designElem xmlns:p16="http://schemas.microsoft.com/office/powerpoint/2015/main" val="1"/>
-              </p:ext>
-            </p:extLst>
-          </p:nvPr>
-        </p:nvSpPr>
-        <p:spPr>
-          <a:xfrm>
-            <a:off x="395893" y="2443480"/>
-            <a:ext cx="3383280" cy="18288"/>
-          </a:xfrm>
-          <a:prstGeom prst="rect">
-            <a:avLst/>
-          </a:prstGeom>
-          <a:solidFill>
-            <a:schemeClr val="tx2">
-              <a:lumMod val="25000"/>
-              <a:lumOff val="75000"/>
-            </a:schemeClr>
-          </a:solidFill>
-          <a:ln w="3175">
-            <a:noFill/>
-          </a:ln>
-          <a:effectLst/>
-        </p:spPr>
-        <p:style>
-          <a:lnRef idx="2">
-            <a:schemeClr val="accent1">
-              <a:shade val="50000"/>
-            </a:schemeClr>
-          </a:lnRef>
-          <a:fillRef idx="1">
-            <a:schemeClr val="accent1"/>
-          </a:fillRef>
-          <a:effectRef idx="0">
-            <a:schemeClr val="accent1"/>
-          </a:effectRef>
-          <a:fontRef idx="minor">
-            <a:schemeClr val="lt1"/>
-          </a:fontRef>
-        </p:style>
-        <p:txBody>
-          <a:bodyPr rtlCol="0" anchor="ctr"/>
-          <a:lstStyle/>
-          <a:p>
-            <a:pPr marL="0" marR="0" lvl="0" indent="0" algn="ctr" defTabSz="914400" rtl="0" eaLnBrk="1" fontAlgn="auto" latinLnBrk="0" hangingPunct="1">
-              <a:lnSpc>
-                <a:spcPct val="100000"/>
-              </a:lnSpc>
-              <a:spcBef>
-                <a:spcPts val="0"/>
-              </a:spcBef>
-              <a:spcAft>
-                <a:spcPts val="0"/>
-              </a:spcAft>
-              <a:buClrTx/>
-              <a:buSzTx/>
-              <a:buFontTx/>
-              <a:buNone/>
-              <a:tabLst/>
-              <a:defRPr/>
-            </a:pPr>
-            <a:endParaRPr kumimoji="0" lang="en-US" sz="1800" b="0" i="0" u="none" strike="noStrike" kern="1200" cap="none" spc="0" normalizeH="0" baseline="0" noProof="0">
-              <a:ln>
-                <a:noFill/>
-              </a:ln>
-              <a:solidFill>
-                <a:prstClr val="white"/>
-              </a:solidFill>
-              <a:effectLst/>
-              <a:uLnTx/>
-              <a:uFillTx/>
-              <a:latin typeface="Calibri" panose="020F0502020204030204"/>
-              <a:ea typeface="+mn-ea"/>
-              <a:cs typeface="+mn-cs"/>
-            </a:endParaRPr>
-          </a:p>
-        </p:txBody>
-      </p:sp>
-      <p:sp>
-        <p:nvSpPr>
-          <p:cNvPr id="3" name="Content Placeholder 2">
-            <a:extLst>
-              <a:ext uri="{FF2B5EF4-FFF2-40B4-BE49-F238E27FC236}">
-                <a16:creationId xmlns:a16="http://schemas.microsoft.com/office/drawing/2014/main" id="{1221E3C7-935B-EB2C-41DA-2AC861B02636}"/>
-              </a:ext>
-            </a:extLst>
-          </p:cNvPr>
-          <p:cNvSpPr>
-            <a:spLocks noGrp="1"/>
-          </p:cNvSpPr>
-          <p:nvPr>
-            <p:ph idx="1"/>
-          </p:nvPr>
-        </p:nvSpPr>
-        <p:spPr>
-          <a:xfrm>
-            <a:off x="371094" y="2718054"/>
-            <a:ext cx="3438906" cy="3207258"/>
-          </a:xfrm>
-        </p:spPr>
-        <p:txBody>
-          <a:bodyPr anchor="t">
-            <a:normAutofit/>
-          </a:bodyPr>
-          <a:lstStyle/>
-          <a:p>
-            <a:r>
-              <a:rPr lang="en-US" sz="1700" dirty="0"/>
-              <a:t>ShadCN – Customizable Component library (</a:t>
-            </a:r>
-            <a:r>
-              <a:rPr lang="en-US" sz="1700" dirty="0">
-                <a:hlinkClick r:id="rId2"/>
-              </a:rPr>
-              <a:t>https://ui.shadcn.com/</a:t>
-            </a:r>
-            <a:r>
-              <a:rPr lang="en-US" sz="1700" dirty="0"/>
-              <a:t>)</a:t>
-            </a:r>
-          </a:p>
-          <a:p>
-            <a:r>
-              <a:rPr lang="en-US" sz="1700" dirty="0" err="1"/>
-              <a:t>AnimateUI</a:t>
-            </a:r>
-            <a:r>
-              <a:rPr lang="en-US" sz="1700" dirty="0"/>
-              <a:t> – Extension of ShadCN offering animated components (</a:t>
-            </a:r>
-            <a:r>
-              <a:rPr lang="en-US" sz="1700" dirty="0">
-                <a:hlinkClick r:id="rId3"/>
-              </a:rPr>
-              <a:t>https://www.shadcn.io/template/animate-ui-animate-ui</a:t>
-            </a:r>
-            <a:r>
-              <a:rPr lang="en-US" sz="1700" dirty="0"/>
-              <a:t>)</a:t>
-            </a:r>
-          </a:p>
-          <a:p>
-            <a:endParaRPr lang="en-US" sz="1700" dirty="0"/>
-          </a:p>
-          <a:p>
-            <a:endParaRPr lang="en-US" sz="1700" dirty="0"/>
-          </a:p>
-        </p:txBody>
-      </p:sp>
       <p:pic>
         <p:nvPicPr>
-          <p:cNvPr id="5" name="Picture 4" descr="A screen shot of a computer program&#10;&#10;AI-generated content may be incorrect.">
-            <a:extLst>
-              <a:ext uri="{FF2B5EF4-FFF2-40B4-BE49-F238E27FC236}">
-                <a16:creationId xmlns:a16="http://schemas.microsoft.com/office/drawing/2014/main" id="{B2CC4308-0F7B-F7F1-E7CA-38BD50DEC1A9}"/>
+          <p:cNvPr id="4" name="Picture 3" descr="A screenshot of a web page&#10;&#10;AI-generated content may be incorrect.">
+            <a:extLst>
+              <a:ext uri="{FF2B5EF4-FFF2-40B4-BE49-F238E27FC236}">
+                <a16:creationId xmlns:a16="http://schemas.microsoft.com/office/drawing/2014/main" id="{50862488-C2A7-56BA-7293-C7EB907526B9}"/>
               </a:ext>
             </a:extLst>
           </p:cNvPr>
@@ -12302,61 +12154,25 @@
           <p:nvPr/>
         </p:nvPicPr>
         <p:blipFill>
-          <a:blip r:embed="rId4"/>
+          <a:blip r:embed="rId3"/>
           <a:stretch>
             <a:fillRect/>
           </a:stretch>
         </p:blipFill>
         <p:spPr>
           <a:xfrm>
-            <a:off x="4898898" y="1426546"/>
-            <a:ext cx="6922008" cy="3132207"/>
+            <a:off x="679545" y="2266813"/>
+            <a:ext cx="6378574" cy="3862350"/>
           </a:xfrm>
           <a:prstGeom prst="rect">
             <a:avLst/>
           </a:prstGeom>
         </p:spPr>
       </p:pic>
-      <p:sp>
-        <p:nvSpPr>
-          <p:cNvPr id="6" name="TextBox 5">
-            <a:extLst>
-              <a:ext uri="{FF2B5EF4-FFF2-40B4-BE49-F238E27FC236}">
-                <a16:creationId xmlns:a16="http://schemas.microsoft.com/office/drawing/2014/main" id="{615FF795-D189-52AF-4F44-45A167668A2C}"/>
-              </a:ext>
-            </a:extLst>
-          </p:cNvPr>
-          <p:cNvSpPr txBox="1"/>
-          <p:nvPr/>
-        </p:nvSpPr>
-        <p:spPr>
-          <a:xfrm>
-            <a:off x="4898899" y="4596279"/>
-            <a:ext cx="6922007" cy="646331"/>
-          </a:xfrm>
-          <a:prstGeom prst="rect">
-            <a:avLst/>
-          </a:prstGeom>
-          <a:noFill/>
-        </p:spPr>
-        <p:txBody>
-          <a:bodyPr wrap="square" rtlCol="0">
-            <a:spAutoFit/>
-          </a:bodyPr>
-          <a:lstStyle/>
-          <a:p>
-            <a:pPr algn="ctr"/>
-            <a:r>
-              <a:rPr lang="en-US" dirty="0"/>
-              <a:t>Only installs modules you specifically download, and allows complete control / customization</a:t>
-            </a:r>
-          </a:p>
-        </p:txBody>
-      </p:sp>
     </p:spTree>
     <p:extLst>
       <p:ext uri="{BB962C8B-B14F-4D97-AF65-F5344CB8AC3E}">
-        <p14:creationId xmlns:p14="http://schemas.microsoft.com/office/powerpoint/2010/main" val="3611386767"/>
+        <p14:creationId xmlns:p14="http://schemas.microsoft.com/office/powerpoint/2010/main" val="3687148187"/>
       </p:ext>
     </p:extLst>
   </p:cSld>

</xml_diff>

<commit_message>
Landing page and Theme setup (#2)
* update theming and add rudimentry header

* update animated grid bg usage

* setup landing page

* add main landing page section

* update header for mobile and tablet

* fix responsive design

* add profile menu and create pages

* add todo note for tomorrow

* update folder name

* remove unecessary comments

* update to theme

* move provider to correct folder

* footer-usage

* update home text color

* update text colors on main pages

---------

Co-authored-by: Connor Robinson <connor.3.robinson@bt.com>
</commit_message>
<xml_diff>
--- a/figma/MMI_Presentation.pptx
+++ b/figma/MMI_Presentation.pptx
@@ -8,8 +8,8 @@
     <p:sldId id="256" r:id="rId2"/>
     <p:sldId id="257" r:id="rId3"/>
     <p:sldId id="258" r:id="rId4"/>
-    <p:sldId id="259" r:id="rId5"/>
-    <p:sldId id="260" r:id="rId6"/>
+    <p:sldId id="274" r:id="rId5"/>
+    <p:sldId id="259" r:id="rId6"/>
     <p:sldId id="266" r:id="rId7"/>
     <p:sldId id="265" r:id="rId8"/>
     <p:sldId id="267" r:id="rId9"/>
@@ -9462,7 +9462,7 @@
           <a:p>
             <a:r>
               <a:rPr lang="en-US" dirty="0"/>
-              <a:t>Prettier (VS Code Auto formats code e.g. keep consistent single quote or double quote usage) </a:t>
+              <a:t>Prettier (Auto formats code e.g. keep consistent single quote or double quote usage) </a:t>
             </a:r>
           </a:p>
         </p:txBody>
@@ -10882,6 +10882,13 @@
               <a:rPr lang="en-US" dirty="0"/>
               <a:t>Tech Stack</a:t>
             </a:r>
+            <a:br>
+              <a:rPr lang="en-US" dirty="0"/>
+            </a:br>
+            <a:r>
+              <a:rPr lang="en-US" dirty="0"/>
+              <a:t>Frontend</a:t>
+            </a:r>
           </a:p>
         </p:txBody>
       </p:sp>
@@ -11038,40 +11045,6 @@
               <a:t>User auth using AWS Amplify + Cognito</a:t>
             </a:r>
           </a:p>
-          <a:p>
-            <a:r>
-              <a:rPr lang="en-US" sz="1900" dirty="0"/>
-              <a:t>Back End:</a:t>
-            </a:r>
-          </a:p>
-          <a:p>
-            <a:pPr lvl="1"/>
-            <a:r>
-              <a:rPr lang="en-US" sz="1900" dirty="0"/>
-              <a:t>NextJS (Api Routes)</a:t>
-            </a:r>
-          </a:p>
-          <a:p>
-            <a:pPr lvl="1"/>
-            <a:r>
-              <a:rPr lang="en-US" sz="1900" dirty="0"/>
-              <a:t>AWS S3 Buckets (file storage e.g. pictures, exported CVs)</a:t>
-            </a:r>
-          </a:p>
-          <a:p>
-            <a:pPr lvl="1"/>
-            <a:r>
-              <a:rPr lang="en-US" sz="1900" dirty="0"/>
-              <a:t>AWS DynamoDB (NoSQL database)</a:t>
-            </a:r>
-          </a:p>
-          <a:p>
-            <a:pPr lvl="1"/>
-            <a:r>
-              <a:rPr lang="en-US" sz="1900" dirty="0"/>
-              <a:t>AWS Cognito (User management and authentication</a:t>
-            </a:r>
-          </a:p>
         </p:txBody>
       </p:sp>
     </p:spTree>
@@ -11088,6 +11061,645 @@
 </file>
 
 <file path=ppt/slides/slide4.xml><?xml version="1.0" encoding="utf-8"?>
+<p:sld xmlns:a="http://schemas.openxmlformats.org/drawingml/2006/main" xmlns:r="http://schemas.openxmlformats.org/officeDocument/2006/relationships" xmlns:p="http://schemas.openxmlformats.org/presentationml/2006/main">
+  <p:cSld>
+    <p:bg>
+      <p:bgPr>
+        <a:solidFill>
+          <a:schemeClr val="bg1"/>
+        </a:solidFill>
+        <a:effectLst/>
+      </p:bgPr>
+    </p:bg>
+    <p:spTree>
+      <p:nvGrpSpPr>
+        <p:cNvPr id="1" name="">
+          <a:extLst>
+            <a:ext uri="{FF2B5EF4-FFF2-40B4-BE49-F238E27FC236}">
+              <a16:creationId xmlns:a16="http://schemas.microsoft.com/office/drawing/2014/main" id="{A4DC52E0-2855-5372-F444-252943EB2ACB}"/>
+            </a:ext>
+          </a:extLst>
+        </p:cNvPr>
+        <p:cNvGrpSpPr/>
+        <p:nvPr/>
+      </p:nvGrpSpPr>
+      <p:grpSpPr>
+        <a:xfrm>
+          <a:off x="0" y="0"/>
+          <a:ext cx="0" cy="0"/>
+          <a:chOff x="0" y="0"/>
+          <a:chExt cx="0" cy="0"/>
+        </a:xfrm>
+      </p:grpSpPr>
+      <p:sp useBgFill="1">
+        <p:nvSpPr>
+          <p:cNvPr id="8" name="Rectangle 7">
+            <a:extLst>
+              <a:ext uri="{FF2B5EF4-FFF2-40B4-BE49-F238E27FC236}">
+                <a16:creationId xmlns:a16="http://schemas.microsoft.com/office/drawing/2014/main" id="{41FFFFDA-CC39-2AFC-F285-352F5ED9454F}"/>
+              </a:ext>
+              <a:ext uri="{C183D7F6-B498-43B3-948B-1728B52AA6E4}">
+                <adec:decorative xmlns:adec="http://schemas.microsoft.com/office/drawing/2017/decorative" val="1"/>
+              </a:ext>
+            </a:extLst>
+          </p:cNvPr>
+          <p:cNvSpPr>
+            <a:spLocks noGrp="1" noRot="1" noChangeAspect="1" noMove="1" noResize="1" noEditPoints="1" noAdjustHandles="1" noChangeArrowheads="1" noChangeShapeType="1" noTextEdit="1"/>
+          </p:cNvSpPr>
+          <p:nvPr>
+            <p:extLst>
+              <p:ext uri="{386F3935-93C4-4BCD-93E2-E3B085C9AB24}">
+                <p16:designElem xmlns:p16="http://schemas.microsoft.com/office/powerpoint/2015/main" val="1"/>
+              </p:ext>
+            </p:extLst>
+          </p:nvPr>
+        </p:nvSpPr>
+        <p:spPr>
+          <a:xfrm>
+            <a:off x="0" y="0"/>
+            <a:ext cx="12192002" cy="6858000"/>
+          </a:xfrm>
+          <a:prstGeom prst="rect">
+            <a:avLst/>
+          </a:prstGeom>
+          <a:ln>
+            <a:noFill/>
+          </a:ln>
+        </p:spPr>
+        <p:style>
+          <a:lnRef idx="2">
+            <a:schemeClr val="accent1">
+              <a:shade val="50000"/>
+            </a:schemeClr>
+          </a:lnRef>
+          <a:fillRef idx="1">
+            <a:schemeClr val="accent1"/>
+          </a:fillRef>
+          <a:effectRef idx="0">
+            <a:schemeClr val="accent1"/>
+          </a:effectRef>
+          <a:fontRef idx="minor">
+            <a:schemeClr val="lt1"/>
+          </a:fontRef>
+        </p:style>
+        <p:txBody>
+          <a:bodyPr rtlCol="0" anchor="ctr"/>
+          <a:lstStyle/>
+          <a:p>
+            <a:pPr algn="ctr"/>
+            <a:endParaRPr lang="en-US"/>
+          </a:p>
+        </p:txBody>
+      </p:sp>
+      <p:sp useBgFill="1">
+        <p:nvSpPr>
+          <p:cNvPr id="10" name="Freeform: Shape 9">
+            <a:extLst>
+              <a:ext uri="{FF2B5EF4-FFF2-40B4-BE49-F238E27FC236}">
+                <a16:creationId xmlns:a16="http://schemas.microsoft.com/office/drawing/2014/main" id="{B4E76E7E-94D2-3C57-5163-BF7FE5A40C1F}"/>
+              </a:ext>
+              <a:ext uri="{C183D7F6-B498-43B3-948B-1728B52AA6E4}">
+                <adec:decorative xmlns:adec="http://schemas.microsoft.com/office/drawing/2017/decorative" val="1"/>
+              </a:ext>
+            </a:extLst>
+          </p:cNvPr>
+          <p:cNvSpPr>
+            <a:spLocks noGrp="1" noRot="1" noChangeAspect="1" noMove="1" noResize="1" noEditPoints="1" noAdjustHandles="1" noChangeArrowheads="1" noChangeShapeType="1" noTextEdit="1"/>
+          </p:cNvSpPr>
+          <p:nvPr>
+            <p:extLst>
+              <p:ext uri="{386F3935-93C4-4BCD-93E2-E3B085C9AB24}">
+                <p16:designElem xmlns:p16="http://schemas.microsoft.com/office/powerpoint/2015/main" val="1"/>
+              </p:ext>
+            </p:extLst>
+          </p:nvPr>
+        </p:nvSpPr>
+        <p:spPr>
+          <a:xfrm>
+            <a:off x="-1" y="0"/>
+            <a:ext cx="4818889" cy="6858000"/>
+          </a:xfrm>
+          <a:custGeom>
+            <a:avLst/>
+            <a:gdLst>
+              <a:gd name="connsiteX0" fmla="*/ 0 w 4818889"/>
+              <a:gd name="connsiteY0" fmla="*/ 0 h 6858000"/>
+              <a:gd name="connsiteX1" fmla="*/ 3605911 w 4818889"/>
+              <a:gd name="connsiteY1" fmla="*/ 0 h 6858000"/>
+              <a:gd name="connsiteX2" fmla="*/ 3668894 w 4818889"/>
+              <a:gd name="connsiteY2" fmla="*/ 69271 h 6858000"/>
+              <a:gd name="connsiteX3" fmla="*/ 4818889 w 4818889"/>
+              <a:gd name="connsiteY3" fmla="*/ 3429000 h 6858000"/>
+              <a:gd name="connsiteX4" fmla="*/ 3668894 w 4818889"/>
+              <a:gd name="connsiteY4" fmla="*/ 6788730 h 6858000"/>
+              <a:gd name="connsiteX5" fmla="*/ 3605911 w 4818889"/>
+              <a:gd name="connsiteY5" fmla="*/ 6858000 h 6858000"/>
+              <a:gd name="connsiteX6" fmla="*/ 0 w 4818889"/>
+              <a:gd name="connsiteY6" fmla="*/ 6858000 h 6858000"/>
+            </a:gdLst>
+            <a:ahLst/>
+            <a:cxnLst>
+              <a:cxn ang="0">
+                <a:pos x="connsiteX0" y="connsiteY0"/>
+              </a:cxn>
+              <a:cxn ang="0">
+                <a:pos x="connsiteX1" y="connsiteY1"/>
+              </a:cxn>
+              <a:cxn ang="0">
+                <a:pos x="connsiteX2" y="connsiteY2"/>
+              </a:cxn>
+              <a:cxn ang="0">
+                <a:pos x="connsiteX3" y="connsiteY3"/>
+              </a:cxn>
+              <a:cxn ang="0">
+                <a:pos x="connsiteX4" y="connsiteY4"/>
+              </a:cxn>
+              <a:cxn ang="0">
+                <a:pos x="connsiteX5" y="connsiteY5"/>
+              </a:cxn>
+              <a:cxn ang="0">
+                <a:pos x="connsiteX6" y="connsiteY6"/>
+              </a:cxn>
+            </a:cxnLst>
+            <a:rect l="l" t="t" r="r" b="b"/>
+            <a:pathLst>
+              <a:path w="4818889" h="6858000">
+                <a:moveTo>
+                  <a:pt x="0" y="0"/>
+                </a:moveTo>
+                <a:lnTo>
+                  <a:pt x="3605911" y="0"/>
+                </a:lnTo>
+                <a:lnTo>
+                  <a:pt x="3668894" y="69271"/>
+                </a:lnTo>
+                <a:cubicBezTo>
+                  <a:pt x="4379420" y="929100"/>
+                  <a:pt x="4818889" y="2116944"/>
+                  <a:pt x="4818889" y="3429000"/>
+                </a:cubicBezTo>
+                <a:cubicBezTo>
+                  <a:pt x="4818889" y="4741056"/>
+                  <a:pt x="4379420" y="5928900"/>
+                  <a:pt x="3668894" y="6788730"/>
+                </a:cubicBezTo>
+                <a:lnTo>
+                  <a:pt x="3605911" y="6858000"/>
+                </a:lnTo>
+                <a:lnTo>
+                  <a:pt x="0" y="6858000"/>
+                </a:lnTo>
+                <a:close/>
+              </a:path>
+            </a:pathLst>
+          </a:custGeom>
+          <a:ln w="9525">
+            <a:solidFill>
+              <a:schemeClr val="tx2">
+                <a:lumMod val="10000"/>
+                <a:lumOff val="90000"/>
+              </a:schemeClr>
+            </a:solidFill>
+          </a:ln>
+          <a:effectLst>
+            <a:outerShdw blurRad="50800" dist="38100" algn="l" rotWithShape="0">
+              <a:schemeClr val="bg1">
+                <a:lumMod val="85000"/>
+                <a:alpha val="30000"/>
+              </a:schemeClr>
+            </a:outerShdw>
+          </a:effectLst>
+        </p:spPr>
+        <p:style>
+          <a:lnRef idx="2">
+            <a:schemeClr val="accent1">
+              <a:shade val="50000"/>
+            </a:schemeClr>
+          </a:lnRef>
+          <a:fillRef idx="1">
+            <a:schemeClr val="accent1"/>
+          </a:fillRef>
+          <a:effectRef idx="0">
+            <a:schemeClr val="accent1"/>
+          </a:effectRef>
+          <a:fontRef idx="minor">
+            <a:schemeClr val="lt1"/>
+          </a:fontRef>
+        </p:style>
+        <p:txBody>
+          <a:bodyPr wrap="square" rtlCol="0" anchor="ctr">
+            <a:noAutofit/>
+          </a:bodyPr>
+          <a:lstStyle/>
+          <a:p>
+            <a:pPr marL="0" marR="0" lvl="0" indent="0" algn="ctr" defTabSz="914400" rtl="0" eaLnBrk="1" fontAlgn="auto" latinLnBrk="0" hangingPunct="1">
+              <a:lnSpc>
+                <a:spcPct val="100000"/>
+              </a:lnSpc>
+              <a:spcBef>
+                <a:spcPts val="0"/>
+              </a:spcBef>
+              <a:spcAft>
+                <a:spcPts val="0"/>
+              </a:spcAft>
+              <a:buClrTx/>
+              <a:buSzTx/>
+              <a:buFontTx/>
+              <a:buNone/>
+              <a:tabLst/>
+              <a:defRPr/>
+            </a:pPr>
+            <a:endParaRPr kumimoji="0" lang="en-US" sz="1800" b="0" i="0" u="none" strike="noStrike" kern="1200" cap="none" spc="0" normalizeH="0" baseline="0" noProof="0">
+              <a:ln>
+                <a:noFill/>
+              </a:ln>
+              <a:solidFill>
+                <a:prstClr val="white"/>
+              </a:solidFill>
+              <a:effectLst/>
+              <a:uLnTx/>
+              <a:uFillTx/>
+              <a:latin typeface="Calibri" panose="020F0502020204030204"/>
+              <a:ea typeface="+mn-ea"/>
+              <a:cs typeface="+mn-cs"/>
+            </a:endParaRPr>
+          </a:p>
+        </p:txBody>
+      </p:sp>
+      <p:sp useBgFill="1">
+        <p:nvSpPr>
+          <p:cNvPr id="12" name="Freeform: Shape 11">
+            <a:extLst>
+              <a:ext uri="{FF2B5EF4-FFF2-40B4-BE49-F238E27FC236}">
+                <a16:creationId xmlns:a16="http://schemas.microsoft.com/office/drawing/2014/main" id="{2D8B66D4-3101-5B1F-C68F-79F98C7E75BB}"/>
+              </a:ext>
+              <a:ext uri="{C183D7F6-B498-43B3-948B-1728B52AA6E4}">
+                <adec:decorative xmlns:adec="http://schemas.microsoft.com/office/drawing/2017/decorative" val="1"/>
+              </a:ext>
+            </a:extLst>
+          </p:cNvPr>
+          <p:cNvSpPr>
+            <a:spLocks noGrp="1" noRot="1" noChangeAspect="1" noMove="1" noResize="1" noEditPoints="1" noAdjustHandles="1" noChangeArrowheads="1" noChangeShapeType="1" noTextEdit="1"/>
+          </p:cNvSpPr>
+          <p:nvPr>
+            <p:extLst>
+              <p:ext uri="{386F3935-93C4-4BCD-93E2-E3B085C9AB24}">
+                <p16:designElem xmlns:p16="http://schemas.microsoft.com/office/powerpoint/2015/main" val="1"/>
+              </p:ext>
+            </p:extLst>
+          </p:nvPr>
+        </p:nvSpPr>
+        <p:spPr>
+          <a:xfrm>
+            <a:off x="1" y="0"/>
+            <a:ext cx="4811477" cy="6858000"/>
+          </a:xfrm>
+          <a:custGeom>
+            <a:avLst/>
+            <a:gdLst>
+              <a:gd name="connsiteX0" fmla="*/ 0 w 4811477"/>
+              <a:gd name="connsiteY0" fmla="*/ 0 h 6858000"/>
+              <a:gd name="connsiteX1" fmla="*/ 3598499 w 4811477"/>
+              <a:gd name="connsiteY1" fmla="*/ 0 h 6858000"/>
+              <a:gd name="connsiteX2" fmla="*/ 3661482 w 4811477"/>
+              <a:gd name="connsiteY2" fmla="*/ 69271 h 6858000"/>
+              <a:gd name="connsiteX3" fmla="*/ 4811477 w 4811477"/>
+              <a:gd name="connsiteY3" fmla="*/ 3429000 h 6858000"/>
+              <a:gd name="connsiteX4" fmla="*/ 3661482 w 4811477"/>
+              <a:gd name="connsiteY4" fmla="*/ 6788730 h 6858000"/>
+              <a:gd name="connsiteX5" fmla="*/ 3598499 w 4811477"/>
+              <a:gd name="connsiteY5" fmla="*/ 6858000 h 6858000"/>
+              <a:gd name="connsiteX6" fmla="*/ 0 w 4811477"/>
+              <a:gd name="connsiteY6" fmla="*/ 6858000 h 6858000"/>
+            </a:gdLst>
+            <a:ahLst/>
+            <a:cxnLst>
+              <a:cxn ang="0">
+                <a:pos x="connsiteX0" y="connsiteY0"/>
+              </a:cxn>
+              <a:cxn ang="0">
+                <a:pos x="connsiteX1" y="connsiteY1"/>
+              </a:cxn>
+              <a:cxn ang="0">
+                <a:pos x="connsiteX2" y="connsiteY2"/>
+              </a:cxn>
+              <a:cxn ang="0">
+                <a:pos x="connsiteX3" y="connsiteY3"/>
+              </a:cxn>
+              <a:cxn ang="0">
+                <a:pos x="connsiteX4" y="connsiteY4"/>
+              </a:cxn>
+              <a:cxn ang="0">
+                <a:pos x="connsiteX5" y="connsiteY5"/>
+              </a:cxn>
+              <a:cxn ang="0">
+                <a:pos x="connsiteX6" y="connsiteY6"/>
+              </a:cxn>
+            </a:cxnLst>
+            <a:rect l="l" t="t" r="r" b="b"/>
+            <a:pathLst>
+              <a:path w="4811477" h="6858000">
+                <a:moveTo>
+                  <a:pt x="0" y="0"/>
+                </a:moveTo>
+                <a:lnTo>
+                  <a:pt x="3598499" y="0"/>
+                </a:lnTo>
+                <a:lnTo>
+                  <a:pt x="3661482" y="69271"/>
+                </a:lnTo>
+                <a:cubicBezTo>
+                  <a:pt x="4372008" y="929100"/>
+                  <a:pt x="4811477" y="2116944"/>
+                  <a:pt x="4811477" y="3429000"/>
+                </a:cubicBezTo>
+                <a:cubicBezTo>
+                  <a:pt x="4811477" y="4741056"/>
+                  <a:pt x="4372008" y="5928900"/>
+                  <a:pt x="3661482" y="6788730"/>
+                </a:cubicBezTo>
+                <a:lnTo>
+                  <a:pt x="3598499" y="6858000"/>
+                </a:lnTo>
+                <a:lnTo>
+                  <a:pt x="0" y="6858000"/>
+                </a:lnTo>
+                <a:close/>
+              </a:path>
+            </a:pathLst>
+          </a:custGeom>
+          <a:ln w="9525">
+            <a:noFill/>
+          </a:ln>
+          <a:effectLst/>
+        </p:spPr>
+        <p:style>
+          <a:lnRef idx="2">
+            <a:schemeClr val="accent1">
+              <a:shade val="50000"/>
+            </a:schemeClr>
+          </a:lnRef>
+          <a:fillRef idx="1">
+            <a:schemeClr val="accent1"/>
+          </a:fillRef>
+          <a:effectRef idx="0">
+            <a:schemeClr val="accent1"/>
+          </a:effectRef>
+          <a:fontRef idx="minor">
+            <a:schemeClr val="lt1"/>
+          </a:fontRef>
+        </p:style>
+        <p:txBody>
+          <a:bodyPr wrap="square" rtlCol="0" anchor="ctr">
+            <a:noAutofit/>
+          </a:bodyPr>
+          <a:lstStyle/>
+          <a:p>
+            <a:pPr marL="0" marR="0" lvl="0" indent="0" algn="ctr" defTabSz="914400" rtl="0" eaLnBrk="1" fontAlgn="auto" latinLnBrk="0" hangingPunct="1">
+              <a:lnSpc>
+                <a:spcPct val="100000"/>
+              </a:lnSpc>
+              <a:spcBef>
+                <a:spcPts val="0"/>
+              </a:spcBef>
+              <a:spcAft>
+                <a:spcPts val="0"/>
+              </a:spcAft>
+              <a:buClrTx/>
+              <a:buSzTx/>
+              <a:buFontTx/>
+              <a:buNone/>
+              <a:tabLst/>
+              <a:defRPr/>
+            </a:pPr>
+            <a:endParaRPr kumimoji="0" lang="en-US" sz="1800" b="0" i="0" u="none" strike="noStrike" kern="1200" cap="none" spc="0" normalizeH="0" baseline="0" noProof="0">
+              <a:ln>
+                <a:noFill/>
+              </a:ln>
+              <a:solidFill>
+                <a:prstClr val="white"/>
+              </a:solidFill>
+              <a:effectLst/>
+              <a:uLnTx/>
+              <a:uFillTx/>
+              <a:latin typeface="Calibri" panose="020F0502020204030204"/>
+              <a:ea typeface="+mn-ea"/>
+              <a:cs typeface="+mn-cs"/>
+            </a:endParaRPr>
+          </a:p>
+        </p:txBody>
+      </p:sp>
+      <p:sp>
+        <p:nvSpPr>
+          <p:cNvPr id="2" name="Title 1">
+            <a:extLst>
+              <a:ext uri="{FF2B5EF4-FFF2-40B4-BE49-F238E27FC236}">
+                <a16:creationId xmlns:a16="http://schemas.microsoft.com/office/drawing/2014/main" id="{BBEE26A7-C0D7-FB88-7334-735BA7067610}"/>
+              </a:ext>
+            </a:extLst>
+          </p:cNvPr>
+          <p:cNvSpPr>
+            <a:spLocks noGrp="1"/>
+          </p:cNvSpPr>
+          <p:nvPr>
+            <p:ph type="title"/>
+          </p:nvPr>
+        </p:nvSpPr>
+        <p:spPr>
+          <a:xfrm>
+            <a:off x="621792" y="1161288"/>
+            <a:ext cx="3602736" cy="4526280"/>
+          </a:xfrm>
+        </p:spPr>
+        <p:txBody>
+          <a:bodyPr>
+            <a:normAutofit/>
+          </a:bodyPr>
+          <a:lstStyle/>
+          <a:p>
+            <a:r>
+              <a:rPr lang="en-US" dirty="0"/>
+              <a:t>Tech Stack</a:t>
+            </a:r>
+            <a:br>
+              <a:rPr lang="en-US" dirty="0"/>
+            </a:br>
+            <a:r>
+              <a:rPr lang="en-US" dirty="0"/>
+              <a:t>Backend</a:t>
+            </a:r>
+          </a:p>
+        </p:txBody>
+      </p:sp>
+      <p:sp>
+        <p:nvSpPr>
+          <p:cNvPr id="14" name="Rectangle 13">
+            <a:extLst>
+              <a:ext uri="{FF2B5EF4-FFF2-40B4-BE49-F238E27FC236}">
+                <a16:creationId xmlns:a16="http://schemas.microsoft.com/office/drawing/2014/main" id="{ACDEC5F4-BF85-6050-7E02-5C8CE6C007E3}"/>
+              </a:ext>
+              <a:ext uri="{C183D7F6-B498-43B3-948B-1728B52AA6E4}">
+                <adec:decorative xmlns:adec="http://schemas.microsoft.com/office/drawing/2017/decorative" val="1"/>
+              </a:ext>
+            </a:extLst>
+          </p:cNvPr>
+          <p:cNvSpPr>
+            <a:spLocks noGrp="1" noRot="1" noChangeAspect="1" noMove="1" noResize="1" noEditPoints="1" noAdjustHandles="1" noChangeArrowheads="1" noChangeShapeType="1" noTextEdit="1"/>
+          </p:cNvSpPr>
+          <p:nvPr>
+            <p:extLst>
+              <p:ext uri="{386F3935-93C4-4BCD-93E2-E3B085C9AB24}">
+                <p16:designElem xmlns:p16="http://schemas.microsoft.com/office/powerpoint/2015/main" val="1"/>
+              </p:ext>
+            </p:extLst>
+          </p:nvPr>
+        </p:nvSpPr>
+        <p:spPr>
+          <a:xfrm>
+            <a:off x="0" y="3102049"/>
+            <a:ext cx="128016" cy="653903"/>
+          </a:xfrm>
+          <a:prstGeom prst="rect">
+            <a:avLst/>
+          </a:prstGeom>
+          <a:solidFill>
+            <a:schemeClr val="accent1"/>
+          </a:solidFill>
+          <a:ln>
+            <a:noFill/>
+          </a:ln>
+        </p:spPr>
+        <p:style>
+          <a:lnRef idx="2">
+            <a:schemeClr val="accent1">
+              <a:shade val="50000"/>
+            </a:schemeClr>
+          </a:lnRef>
+          <a:fillRef idx="1">
+            <a:schemeClr val="accent1"/>
+          </a:fillRef>
+          <a:effectRef idx="0">
+            <a:schemeClr val="accent1"/>
+          </a:effectRef>
+          <a:fontRef idx="minor">
+            <a:schemeClr val="lt1"/>
+          </a:fontRef>
+        </p:style>
+        <p:txBody>
+          <a:bodyPr rtlCol="0" anchor="ctr"/>
+          <a:lstStyle/>
+          <a:p>
+            <a:pPr marL="0" marR="0" lvl="0" indent="0" algn="ctr" defTabSz="914400" rtl="0" eaLnBrk="1" fontAlgn="auto" latinLnBrk="0" hangingPunct="1">
+              <a:lnSpc>
+                <a:spcPct val="100000"/>
+              </a:lnSpc>
+              <a:spcBef>
+                <a:spcPts val="0"/>
+              </a:spcBef>
+              <a:spcAft>
+                <a:spcPts val="0"/>
+              </a:spcAft>
+              <a:buClrTx/>
+              <a:buSzTx/>
+              <a:buFontTx/>
+              <a:buNone/>
+              <a:tabLst/>
+              <a:defRPr/>
+            </a:pPr>
+            <a:endParaRPr kumimoji="0" lang="en-US" sz="1800" b="0" i="0" u="none" strike="noStrike" kern="1200" cap="none" spc="0" normalizeH="0" baseline="0" noProof="0">
+              <a:ln>
+                <a:noFill/>
+              </a:ln>
+              <a:solidFill>
+                <a:prstClr val="white"/>
+              </a:solidFill>
+              <a:effectLst/>
+              <a:uLnTx/>
+              <a:uFillTx/>
+              <a:latin typeface="Calibri" panose="020F0502020204030204"/>
+              <a:ea typeface="+mn-ea"/>
+              <a:cs typeface="+mn-cs"/>
+            </a:endParaRPr>
+          </a:p>
+        </p:txBody>
+      </p:sp>
+      <p:sp>
+        <p:nvSpPr>
+          <p:cNvPr id="3" name="Content Placeholder 2">
+            <a:extLst>
+              <a:ext uri="{FF2B5EF4-FFF2-40B4-BE49-F238E27FC236}">
+                <a16:creationId xmlns:a16="http://schemas.microsoft.com/office/drawing/2014/main" id="{19D5A7A0-9C0D-F227-6D22-CED680F6DA89}"/>
+              </a:ext>
+            </a:extLst>
+          </p:cNvPr>
+          <p:cNvSpPr>
+            <a:spLocks noGrp="1"/>
+          </p:cNvSpPr>
+          <p:nvPr>
+            <p:ph idx="1"/>
+          </p:nvPr>
+        </p:nvSpPr>
+        <p:spPr>
+          <a:xfrm>
+            <a:off x="5434149" y="932688"/>
+            <a:ext cx="5916603" cy="4992624"/>
+          </a:xfrm>
+        </p:spPr>
+        <p:txBody>
+          <a:bodyPr anchor="ctr">
+            <a:normAutofit/>
+          </a:bodyPr>
+          <a:lstStyle/>
+          <a:p>
+            <a:r>
+              <a:rPr lang="en-US" sz="1900" dirty="0"/>
+              <a:t>Back End:</a:t>
+            </a:r>
+          </a:p>
+          <a:p>
+            <a:pPr lvl="1"/>
+            <a:r>
+              <a:rPr lang="en-US" sz="1900" dirty="0"/>
+              <a:t>NextJS (Api Routes)</a:t>
+            </a:r>
+          </a:p>
+          <a:p>
+            <a:pPr lvl="1"/>
+            <a:r>
+              <a:rPr lang="en-US" sz="1900" dirty="0"/>
+              <a:t>AWS S3 Buckets (file storage e.g. pictures, exported CVs)</a:t>
+            </a:r>
+          </a:p>
+          <a:p>
+            <a:pPr lvl="1"/>
+            <a:r>
+              <a:rPr lang="en-US" sz="1900" dirty="0"/>
+              <a:t>AWS DynamoDB (NoSQL database)</a:t>
+            </a:r>
+          </a:p>
+          <a:p>
+            <a:pPr lvl="1"/>
+            <a:r>
+              <a:rPr lang="en-US" sz="1900" dirty="0"/>
+              <a:t>AWS Cognito (User management and authentication.</a:t>
+            </a:r>
+          </a:p>
+        </p:txBody>
+      </p:sp>
+    </p:spTree>
+    <p:extLst>
+      <p:ext uri="{BB962C8B-B14F-4D97-AF65-F5344CB8AC3E}">
+        <p14:creationId xmlns:p14="http://schemas.microsoft.com/office/powerpoint/2010/main" val="3366428917"/>
+      </p:ext>
+    </p:extLst>
+  </p:cSld>
+  <p:clrMapOvr>
+    <a:masterClrMapping/>
+  </p:clrMapOvr>
+</p:sld>
+</file>
+
+<file path=ppt/slides/slide5.xml><?xml version="1.0" encoding="utf-8"?>
 <p:sld xmlns:a="http://schemas.openxmlformats.org/drawingml/2006/main" xmlns:r="http://schemas.openxmlformats.org/officeDocument/2006/relationships" xmlns:p="http://schemas.openxmlformats.org/presentationml/2006/main">
   <p:cSld>
     <p:bg>
@@ -11499,10 +12111,10 @@
       </p:sp>
       <p:pic>
         <p:nvPicPr>
-          <p:cNvPr id="5" name="Picture 4" descr="A screenshot of a computer&#10;&#10;AI-generated content may be incorrect.">
-            <a:extLst>
-              <a:ext uri="{FF2B5EF4-FFF2-40B4-BE49-F238E27FC236}">
-                <a16:creationId xmlns:a16="http://schemas.microsoft.com/office/drawing/2014/main" id="{9BD6BBB6-13ED-CCC5-6D30-A568FC15C9F2}"/>
+          <p:cNvPr id="8" name="Picture 7" descr="A screenshot of a login page&#10;&#10;AI-generated content may be incorrect.">
+            <a:extLst>
+              <a:ext uri="{FF2B5EF4-FFF2-40B4-BE49-F238E27FC236}">
+                <a16:creationId xmlns:a16="http://schemas.microsoft.com/office/drawing/2014/main" id="{3556042F-7362-0347-7411-CA9789DFC4C5}"/>
               </a:ext>
             </a:extLst>
           </p:cNvPr>
@@ -11513,36 +12125,6 @@
         </p:nvPicPr>
         <p:blipFill>
           <a:blip r:embed="rId2"/>
-          <a:stretch>
-            <a:fillRect/>
-          </a:stretch>
-        </p:blipFill>
-        <p:spPr>
-          <a:xfrm>
-            <a:off x="473583" y="2171760"/>
-            <a:ext cx="6463647" cy="3889143"/>
-          </a:xfrm>
-          <a:prstGeom prst="rect">
-            <a:avLst/>
-          </a:prstGeom>
-        </p:spPr>
-      </p:pic>
-      <p:pic>
-        <p:nvPicPr>
-          <p:cNvPr id="8" name="Picture 7" descr="A screenshot of a login page&#10;&#10;AI-generated content may be incorrect.">
-            <a:extLst>
-              <a:ext uri="{FF2B5EF4-FFF2-40B4-BE49-F238E27FC236}">
-                <a16:creationId xmlns:a16="http://schemas.microsoft.com/office/drawing/2014/main" id="{3556042F-7362-0347-7411-CA9789DFC4C5}"/>
-              </a:ext>
-            </a:extLst>
-          </p:cNvPr>
-          <p:cNvPicPr>
-            <a:picLocks noChangeAspect="1"/>
-          </p:cNvPicPr>
-          <p:nvPr/>
-        </p:nvPicPr>
-        <p:blipFill>
-          <a:blip r:embed="rId3"/>
           <a:stretch>
             <a:fillRect/>
           </a:stretch>
@@ -11557,742 +12139,12 @@
           </a:prstGeom>
         </p:spPr>
       </p:pic>
-    </p:spTree>
-    <p:extLst>
-      <p:ext uri="{BB962C8B-B14F-4D97-AF65-F5344CB8AC3E}">
-        <p14:creationId xmlns:p14="http://schemas.microsoft.com/office/powerpoint/2010/main" val="3687148187"/>
-      </p:ext>
-    </p:extLst>
-  </p:cSld>
-  <p:clrMapOvr>
-    <a:masterClrMapping/>
-  </p:clrMapOvr>
-</p:sld>
-</file>
-
-<file path=ppt/slides/slide5.xml><?xml version="1.0" encoding="utf-8"?>
-<p:sld xmlns:a="http://schemas.openxmlformats.org/drawingml/2006/main" xmlns:r="http://schemas.openxmlformats.org/officeDocument/2006/relationships" xmlns:p="http://schemas.openxmlformats.org/presentationml/2006/main">
-  <p:cSld>
-    <p:bg>
-      <p:bgPr>
-        <a:solidFill>
-          <a:schemeClr val="bg1"/>
-        </a:solidFill>
-        <a:effectLst/>
-      </p:bgPr>
-    </p:bg>
-    <p:spTree>
-      <p:nvGrpSpPr>
-        <p:cNvPr id="1" name=""/>
-        <p:cNvGrpSpPr/>
-        <p:nvPr/>
-      </p:nvGrpSpPr>
-      <p:grpSpPr>
-        <a:xfrm>
-          <a:off x="0" y="0"/>
-          <a:ext cx="0" cy="0"/>
-          <a:chOff x="0" y="0"/>
-          <a:chExt cx="0" cy="0"/>
-        </a:xfrm>
-      </p:grpSpPr>
-      <p:sp useBgFill="1">
-        <p:nvSpPr>
-          <p:cNvPr id="10" name="Rectangle 9">
-            <a:extLst>
-              <a:ext uri="{FF2B5EF4-FFF2-40B4-BE49-F238E27FC236}">
-                <a16:creationId xmlns:a16="http://schemas.microsoft.com/office/drawing/2014/main" id="{0288C6B4-AFC3-407F-A595-EFFD38D4CCAF}"/>
-              </a:ext>
-              <a:ext uri="{C183D7F6-B498-43B3-948B-1728B52AA6E4}">
-                <adec:decorative xmlns:adec="http://schemas.microsoft.com/office/drawing/2017/decorative" val="1"/>
-              </a:ext>
-            </a:extLst>
-          </p:cNvPr>
-          <p:cNvSpPr>
-            <a:spLocks noGrp="1" noRot="1" noChangeAspect="1" noMove="1" noResize="1" noEditPoints="1" noAdjustHandles="1" noChangeArrowheads="1" noChangeShapeType="1" noTextEdit="1"/>
-          </p:cNvSpPr>
-          <p:nvPr>
-            <p:extLst>
-              <p:ext uri="{386F3935-93C4-4BCD-93E2-E3B085C9AB24}">
-                <p16:designElem xmlns:p16="http://schemas.microsoft.com/office/powerpoint/2015/main" val="1"/>
-              </p:ext>
-            </p:extLst>
-          </p:nvPr>
-        </p:nvSpPr>
-        <p:spPr>
-          <a:xfrm>
-            <a:off x="0" y="0"/>
-            <a:ext cx="12192000" cy="6858000"/>
-          </a:xfrm>
-          <a:prstGeom prst="rect">
-            <a:avLst/>
-          </a:prstGeom>
-          <a:ln>
-            <a:noFill/>
-          </a:ln>
-        </p:spPr>
-        <p:style>
-          <a:lnRef idx="2">
-            <a:schemeClr val="accent1">
-              <a:shade val="50000"/>
-            </a:schemeClr>
-          </a:lnRef>
-          <a:fillRef idx="1">
-            <a:schemeClr val="accent1"/>
-          </a:fillRef>
-          <a:effectRef idx="0">
-            <a:schemeClr val="accent1"/>
-          </a:effectRef>
-          <a:fontRef idx="minor">
-            <a:schemeClr val="lt1"/>
-          </a:fontRef>
-        </p:style>
-        <p:txBody>
-          <a:bodyPr rtlCol="0" anchor="ctr"/>
-          <a:lstStyle/>
-          <a:p>
-            <a:pPr algn="ctr"/>
-            <a:endParaRPr lang="en-US"/>
-          </a:p>
-        </p:txBody>
-      </p:sp>
-      <p:sp useBgFill="1">
-        <p:nvSpPr>
-          <p:cNvPr id="12" name="Freeform: Shape 11">
-            <a:extLst>
-              <a:ext uri="{FF2B5EF4-FFF2-40B4-BE49-F238E27FC236}">
-                <a16:creationId xmlns:a16="http://schemas.microsoft.com/office/drawing/2014/main" id="{CF236821-17FE-429B-8D2C-08E13A64EA40}"/>
-              </a:ext>
-              <a:ext uri="{C183D7F6-B498-43B3-948B-1728B52AA6E4}">
-                <adec:decorative xmlns:adec="http://schemas.microsoft.com/office/drawing/2017/decorative" val="1"/>
-              </a:ext>
-            </a:extLst>
-          </p:cNvPr>
-          <p:cNvSpPr>
-            <a:spLocks noGrp="1" noRot="1" noChangeAspect="1" noMove="1" noResize="1" noEditPoints="1" noAdjustHandles="1" noChangeArrowheads="1" noChangeShapeType="1" noTextEdit="1"/>
-          </p:cNvSpPr>
-          <p:nvPr>
-            <p:extLst>
-              <p:ext uri="{386F3935-93C4-4BCD-93E2-E3B085C9AB24}">
-                <p16:designElem xmlns:p16="http://schemas.microsoft.com/office/powerpoint/2015/main" val="1"/>
-              </p:ext>
-            </p:extLst>
-          </p:nvPr>
-        </p:nvSpPr>
-        <p:spPr>
-          <a:xfrm>
-            <a:off x="-1" y="0"/>
-            <a:ext cx="4455673" cy="6858000"/>
-          </a:xfrm>
-          <a:custGeom>
-            <a:avLst/>
-            <a:gdLst>
-              <a:gd name="connsiteX0" fmla="*/ 0 w 4455673"/>
-              <a:gd name="connsiteY0" fmla="*/ 0 h 6858000"/>
-              <a:gd name="connsiteX1" fmla="*/ 3242695 w 4455673"/>
-              <a:gd name="connsiteY1" fmla="*/ 0 h 6858000"/>
-              <a:gd name="connsiteX2" fmla="*/ 3305678 w 4455673"/>
-              <a:gd name="connsiteY2" fmla="*/ 69271 h 6858000"/>
-              <a:gd name="connsiteX3" fmla="*/ 4455673 w 4455673"/>
-              <a:gd name="connsiteY3" fmla="*/ 3429000 h 6858000"/>
-              <a:gd name="connsiteX4" fmla="*/ 3305678 w 4455673"/>
-              <a:gd name="connsiteY4" fmla="*/ 6788730 h 6858000"/>
-              <a:gd name="connsiteX5" fmla="*/ 3242695 w 4455673"/>
-              <a:gd name="connsiteY5" fmla="*/ 6858000 h 6858000"/>
-              <a:gd name="connsiteX6" fmla="*/ 0 w 4455673"/>
-              <a:gd name="connsiteY6" fmla="*/ 6858000 h 6858000"/>
-            </a:gdLst>
-            <a:ahLst/>
-            <a:cxnLst>
-              <a:cxn ang="0">
-                <a:pos x="connsiteX0" y="connsiteY0"/>
-              </a:cxn>
-              <a:cxn ang="0">
-                <a:pos x="connsiteX1" y="connsiteY1"/>
-              </a:cxn>
-              <a:cxn ang="0">
-                <a:pos x="connsiteX2" y="connsiteY2"/>
-              </a:cxn>
-              <a:cxn ang="0">
-                <a:pos x="connsiteX3" y="connsiteY3"/>
-              </a:cxn>
-              <a:cxn ang="0">
-                <a:pos x="connsiteX4" y="connsiteY4"/>
-              </a:cxn>
-              <a:cxn ang="0">
-                <a:pos x="connsiteX5" y="connsiteY5"/>
-              </a:cxn>
-              <a:cxn ang="0">
-                <a:pos x="connsiteX6" y="connsiteY6"/>
-              </a:cxn>
-            </a:cxnLst>
-            <a:rect l="l" t="t" r="r" b="b"/>
-            <a:pathLst>
-              <a:path w="4455673" h="6858000">
-                <a:moveTo>
-                  <a:pt x="0" y="0"/>
-                </a:moveTo>
-                <a:lnTo>
-                  <a:pt x="3242695" y="0"/>
-                </a:lnTo>
-                <a:lnTo>
-                  <a:pt x="3305678" y="69271"/>
-                </a:lnTo>
-                <a:cubicBezTo>
-                  <a:pt x="4016204" y="929100"/>
-                  <a:pt x="4455673" y="2116944"/>
-                  <a:pt x="4455673" y="3429000"/>
-                </a:cubicBezTo>
-                <a:cubicBezTo>
-                  <a:pt x="4455673" y="4741056"/>
-                  <a:pt x="4016204" y="5928900"/>
-                  <a:pt x="3305678" y="6788730"/>
-                </a:cubicBezTo>
-                <a:lnTo>
-                  <a:pt x="3242695" y="6858000"/>
-                </a:lnTo>
-                <a:lnTo>
-                  <a:pt x="0" y="6858000"/>
-                </a:lnTo>
-                <a:close/>
-              </a:path>
-            </a:pathLst>
-          </a:custGeom>
-          <a:ln w="9525">
-            <a:solidFill>
-              <a:schemeClr val="tx2">
-                <a:lumMod val="10000"/>
-                <a:lumOff val="90000"/>
-              </a:schemeClr>
-            </a:solidFill>
-          </a:ln>
-          <a:effectLst>
-            <a:outerShdw blurRad="50800" dist="38100" algn="l" rotWithShape="0">
-              <a:schemeClr val="bg1">
-                <a:lumMod val="85000"/>
-                <a:alpha val="30000"/>
-              </a:schemeClr>
-            </a:outerShdw>
-          </a:effectLst>
-        </p:spPr>
-        <p:style>
-          <a:lnRef idx="2">
-            <a:schemeClr val="accent1">
-              <a:shade val="50000"/>
-            </a:schemeClr>
-          </a:lnRef>
-          <a:fillRef idx="1">
-            <a:schemeClr val="accent1"/>
-          </a:fillRef>
-          <a:effectRef idx="0">
-            <a:schemeClr val="accent1"/>
-          </a:effectRef>
-          <a:fontRef idx="minor">
-            <a:schemeClr val="lt1"/>
-          </a:fontRef>
-        </p:style>
-        <p:txBody>
-          <a:bodyPr wrap="square" rtlCol="0" anchor="ctr">
-            <a:noAutofit/>
-          </a:bodyPr>
-          <a:lstStyle/>
-          <a:p>
-            <a:pPr marL="0" marR="0" lvl="0" indent="0" algn="ctr" defTabSz="914400" rtl="0" eaLnBrk="1" fontAlgn="auto" latinLnBrk="0" hangingPunct="1">
-              <a:lnSpc>
-                <a:spcPct val="100000"/>
-              </a:lnSpc>
-              <a:spcBef>
-                <a:spcPts val="0"/>
-              </a:spcBef>
-              <a:spcAft>
-                <a:spcPts val="0"/>
-              </a:spcAft>
-              <a:buClrTx/>
-              <a:buSzTx/>
-              <a:buFontTx/>
-              <a:buNone/>
-              <a:tabLst/>
-              <a:defRPr/>
-            </a:pPr>
-            <a:endParaRPr kumimoji="0" lang="en-US" sz="1800" b="0" i="0" u="none" strike="noStrike" kern="1200" cap="none" spc="0" normalizeH="0" baseline="0" noProof="0">
-              <a:ln>
-                <a:noFill/>
-              </a:ln>
-              <a:solidFill>
-                <a:prstClr val="white"/>
-              </a:solidFill>
-              <a:effectLst/>
-              <a:uLnTx/>
-              <a:uFillTx/>
-              <a:latin typeface="Calibri" panose="020F0502020204030204"/>
-              <a:ea typeface="+mn-ea"/>
-              <a:cs typeface="+mn-cs"/>
-            </a:endParaRPr>
-          </a:p>
-        </p:txBody>
-      </p:sp>
-      <p:sp useBgFill="1">
-        <p:nvSpPr>
-          <p:cNvPr id="14" name="Freeform: Shape 13">
-            <a:extLst>
-              <a:ext uri="{FF2B5EF4-FFF2-40B4-BE49-F238E27FC236}">
-                <a16:creationId xmlns:a16="http://schemas.microsoft.com/office/drawing/2014/main" id="{C0BDBCD2-E081-43AB-9119-C55465E59757}"/>
-              </a:ext>
-              <a:ext uri="{C183D7F6-B498-43B3-948B-1728B52AA6E4}">
-                <adec:decorative xmlns:adec="http://schemas.microsoft.com/office/drawing/2017/decorative" val="1"/>
-              </a:ext>
-            </a:extLst>
-          </p:cNvPr>
-          <p:cNvSpPr>
-            <a:spLocks noGrp="1" noRot="1" noChangeAspect="1" noMove="1" noResize="1" noEditPoints="1" noAdjustHandles="1" noChangeArrowheads="1" noChangeShapeType="1" noTextEdit="1"/>
-          </p:cNvSpPr>
-          <p:nvPr>
-            <p:extLst>
-              <p:ext uri="{386F3935-93C4-4BCD-93E2-E3B085C9AB24}">
-                <p16:designElem xmlns:p16="http://schemas.microsoft.com/office/powerpoint/2015/main" val="1"/>
-              </p:ext>
-            </p:extLst>
-          </p:nvPr>
-        </p:nvSpPr>
-        <p:spPr>
-          <a:xfrm>
-            <a:off x="0" y="0"/>
-            <a:ext cx="4446529" cy="6858000"/>
-          </a:xfrm>
-          <a:custGeom>
-            <a:avLst/>
-            <a:gdLst>
-              <a:gd name="connsiteX0" fmla="*/ 0 w 4446529"/>
-              <a:gd name="connsiteY0" fmla="*/ 0 h 6858000"/>
-              <a:gd name="connsiteX1" fmla="*/ 3233551 w 4446529"/>
-              <a:gd name="connsiteY1" fmla="*/ 0 h 6858000"/>
-              <a:gd name="connsiteX2" fmla="*/ 3296534 w 4446529"/>
-              <a:gd name="connsiteY2" fmla="*/ 69271 h 6858000"/>
-              <a:gd name="connsiteX3" fmla="*/ 4446529 w 4446529"/>
-              <a:gd name="connsiteY3" fmla="*/ 3429000 h 6858000"/>
-              <a:gd name="connsiteX4" fmla="*/ 3296534 w 4446529"/>
-              <a:gd name="connsiteY4" fmla="*/ 6788730 h 6858000"/>
-              <a:gd name="connsiteX5" fmla="*/ 3233551 w 4446529"/>
-              <a:gd name="connsiteY5" fmla="*/ 6858000 h 6858000"/>
-              <a:gd name="connsiteX6" fmla="*/ 0 w 4446529"/>
-              <a:gd name="connsiteY6" fmla="*/ 6858000 h 6858000"/>
-            </a:gdLst>
-            <a:ahLst/>
-            <a:cxnLst>
-              <a:cxn ang="0">
-                <a:pos x="connsiteX0" y="connsiteY0"/>
-              </a:cxn>
-              <a:cxn ang="0">
-                <a:pos x="connsiteX1" y="connsiteY1"/>
-              </a:cxn>
-              <a:cxn ang="0">
-                <a:pos x="connsiteX2" y="connsiteY2"/>
-              </a:cxn>
-              <a:cxn ang="0">
-                <a:pos x="connsiteX3" y="connsiteY3"/>
-              </a:cxn>
-              <a:cxn ang="0">
-                <a:pos x="connsiteX4" y="connsiteY4"/>
-              </a:cxn>
-              <a:cxn ang="0">
-                <a:pos x="connsiteX5" y="connsiteY5"/>
-              </a:cxn>
-              <a:cxn ang="0">
-                <a:pos x="connsiteX6" y="connsiteY6"/>
-              </a:cxn>
-            </a:cxnLst>
-            <a:rect l="l" t="t" r="r" b="b"/>
-            <a:pathLst>
-              <a:path w="4446529" h="6858000">
-                <a:moveTo>
-                  <a:pt x="0" y="0"/>
-                </a:moveTo>
-                <a:lnTo>
-                  <a:pt x="3233551" y="0"/>
-                </a:lnTo>
-                <a:lnTo>
-                  <a:pt x="3296534" y="69271"/>
-                </a:lnTo>
-                <a:cubicBezTo>
-                  <a:pt x="4007060" y="929100"/>
-                  <a:pt x="4446529" y="2116944"/>
-                  <a:pt x="4446529" y="3429000"/>
-                </a:cubicBezTo>
-                <a:cubicBezTo>
-                  <a:pt x="4446529" y="4741056"/>
-                  <a:pt x="4007060" y="5928900"/>
-                  <a:pt x="3296534" y="6788730"/>
-                </a:cubicBezTo>
-                <a:lnTo>
-                  <a:pt x="3233551" y="6858000"/>
-                </a:lnTo>
-                <a:lnTo>
-                  <a:pt x="0" y="6858000"/>
-                </a:lnTo>
-                <a:close/>
-              </a:path>
-            </a:pathLst>
-          </a:custGeom>
-          <a:ln w="9525">
-            <a:noFill/>
-          </a:ln>
-          <a:effectLst/>
-        </p:spPr>
-        <p:style>
-          <a:lnRef idx="2">
-            <a:schemeClr val="accent1">
-              <a:shade val="50000"/>
-            </a:schemeClr>
-          </a:lnRef>
-          <a:fillRef idx="1">
-            <a:schemeClr val="accent1"/>
-          </a:fillRef>
-          <a:effectRef idx="0">
-            <a:schemeClr val="accent1"/>
-          </a:effectRef>
-          <a:fontRef idx="minor">
-            <a:schemeClr val="lt1"/>
-          </a:fontRef>
-        </p:style>
-        <p:txBody>
-          <a:bodyPr wrap="square" rtlCol="0" anchor="ctr">
-            <a:noAutofit/>
-          </a:bodyPr>
-          <a:lstStyle/>
-          <a:p>
-            <a:pPr marL="0" marR="0" lvl="0" indent="0" algn="ctr" defTabSz="914400" rtl="0" eaLnBrk="1" fontAlgn="auto" latinLnBrk="0" hangingPunct="1">
-              <a:lnSpc>
-                <a:spcPct val="100000"/>
-              </a:lnSpc>
-              <a:spcBef>
-                <a:spcPts val="0"/>
-              </a:spcBef>
-              <a:spcAft>
-                <a:spcPts val="0"/>
-              </a:spcAft>
-              <a:buClrTx/>
-              <a:buSzTx/>
-              <a:buFontTx/>
-              <a:buNone/>
-              <a:tabLst/>
-              <a:defRPr/>
-            </a:pPr>
-            <a:endParaRPr kumimoji="0" lang="en-US" sz="1800" b="0" i="0" u="none" strike="noStrike" kern="1200" cap="none" spc="0" normalizeH="0" baseline="0" noProof="0">
-              <a:ln>
-                <a:noFill/>
-              </a:ln>
-              <a:solidFill>
-                <a:prstClr val="white"/>
-              </a:solidFill>
-              <a:effectLst/>
-              <a:uLnTx/>
-              <a:uFillTx/>
-              <a:latin typeface="Calibri" panose="020F0502020204030204"/>
-              <a:ea typeface="+mn-ea"/>
-              <a:cs typeface="+mn-cs"/>
-            </a:endParaRPr>
-          </a:p>
-        </p:txBody>
-      </p:sp>
-      <p:sp>
-        <p:nvSpPr>
-          <p:cNvPr id="2" name="Title 1">
-            <a:extLst>
-              <a:ext uri="{FF2B5EF4-FFF2-40B4-BE49-F238E27FC236}">
-                <a16:creationId xmlns:a16="http://schemas.microsoft.com/office/drawing/2014/main" id="{3E15C890-08D3-8E45-4BF8-1BA2C5A1A4DA}"/>
-              </a:ext>
-            </a:extLst>
-          </p:cNvPr>
-          <p:cNvSpPr>
-            <a:spLocks noGrp="1"/>
-          </p:cNvSpPr>
-          <p:nvPr>
-            <p:ph type="title"/>
-          </p:nvPr>
-        </p:nvSpPr>
-        <p:spPr>
-          <a:xfrm>
-            <a:off x="371094" y="1161288"/>
-            <a:ext cx="3438144" cy="1239012"/>
-          </a:xfrm>
-        </p:spPr>
-        <p:txBody>
-          <a:bodyPr anchor="ctr">
-            <a:normAutofit/>
-          </a:bodyPr>
-          <a:lstStyle/>
-          <a:p>
-            <a:r>
-              <a:rPr lang="en-US" sz="2600"/>
-              <a:t>Design – Component Library</a:t>
-            </a:r>
-          </a:p>
-        </p:txBody>
-      </p:sp>
-      <p:sp>
-        <p:nvSpPr>
-          <p:cNvPr id="16" name="Rectangle 15">
-            <a:extLst>
-              <a:ext uri="{FF2B5EF4-FFF2-40B4-BE49-F238E27FC236}">
-                <a16:creationId xmlns:a16="http://schemas.microsoft.com/office/drawing/2014/main" id="{98E79BE4-34FE-485A-98A5-92CE8F7C4743}"/>
-              </a:ext>
-              <a:ext uri="{C183D7F6-B498-43B3-948B-1728B52AA6E4}">
-                <adec:decorative xmlns:adec="http://schemas.microsoft.com/office/drawing/2017/decorative" val="1"/>
-              </a:ext>
-            </a:extLst>
-          </p:cNvPr>
-          <p:cNvSpPr>
-            <a:spLocks noGrp="1" noRot="1" noChangeAspect="1" noMove="1" noResize="1" noEditPoints="1" noAdjustHandles="1" noChangeArrowheads="1" noChangeShapeType="1" noTextEdit="1"/>
-          </p:cNvSpPr>
-          <p:nvPr>
-            <p:extLst>
-              <p:ext uri="{386F3935-93C4-4BCD-93E2-E3B085C9AB24}">
-                <p16:designElem xmlns:p16="http://schemas.microsoft.com/office/powerpoint/2015/main" val="1"/>
-              </p:ext>
-            </p:extLst>
-          </p:nvPr>
-        </p:nvSpPr>
-        <p:spPr>
-          <a:xfrm>
-            <a:off x="0" y="1426546"/>
-            <a:ext cx="128016" cy="653903"/>
-          </a:xfrm>
-          <a:prstGeom prst="rect">
-            <a:avLst/>
-          </a:prstGeom>
-          <a:solidFill>
-            <a:schemeClr val="accent1"/>
-          </a:solidFill>
-          <a:ln>
-            <a:noFill/>
-          </a:ln>
-        </p:spPr>
-        <p:style>
-          <a:lnRef idx="2">
-            <a:schemeClr val="accent1">
-              <a:shade val="50000"/>
-            </a:schemeClr>
-          </a:lnRef>
-          <a:fillRef idx="1">
-            <a:schemeClr val="accent1"/>
-          </a:fillRef>
-          <a:effectRef idx="0">
-            <a:schemeClr val="accent1"/>
-          </a:effectRef>
-          <a:fontRef idx="minor">
-            <a:schemeClr val="lt1"/>
-          </a:fontRef>
-        </p:style>
-        <p:txBody>
-          <a:bodyPr rtlCol="0" anchor="ctr"/>
-          <a:lstStyle/>
-          <a:p>
-            <a:pPr marL="0" marR="0" lvl="0" indent="0" algn="ctr" defTabSz="914400" rtl="0" eaLnBrk="1" fontAlgn="auto" latinLnBrk="0" hangingPunct="1">
-              <a:lnSpc>
-                <a:spcPct val="100000"/>
-              </a:lnSpc>
-              <a:spcBef>
-                <a:spcPts val="0"/>
-              </a:spcBef>
-              <a:spcAft>
-                <a:spcPts val="0"/>
-              </a:spcAft>
-              <a:buClrTx/>
-              <a:buSzTx/>
-              <a:buFontTx/>
-              <a:buNone/>
-              <a:tabLst/>
-              <a:defRPr/>
-            </a:pPr>
-            <a:endParaRPr kumimoji="0" lang="en-US" sz="1800" b="0" i="0" u="none" strike="noStrike" kern="1200" cap="none" spc="0" normalizeH="0" baseline="0" noProof="0">
-              <a:ln>
-                <a:noFill/>
-              </a:ln>
-              <a:solidFill>
-                <a:prstClr val="white"/>
-              </a:solidFill>
-              <a:effectLst/>
-              <a:uLnTx/>
-              <a:uFillTx/>
-              <a:latin typeface="Calibri" panose="020F0502020204030204"/>
-              <a:ea typeface="+mn-ea"/>
-              <a:cs typeface="+mn-cs"/>
-            </a:endParaRPr>
-          </a:p>
-        </p:txBody>
-      </p:sp>
-      <p:sp>
-        <p:nvSpPr>
-          <p:cNvPr id="18" name="Rectangle 17">
-            <a:extLst>
-              <a:ext uri="{FF2B5EF4-FFF2-40B4-BE49-F238E27FC236}">
-                <a16:creationId xmlns:a16="http://schemas.microsoft.com/office/drawing/2014/main" id="{7A5F0580-5EE9-419F-96EE-B6529EF6E7D0}"/>
-              </a:ext>
-              <a:ext uri="{C183D7F6-B498-43B3-948B-1728B52AA6E4}">
-                <adec:decorative xmlns:adec="http://schemas.microsoft.com/office/drawing/2017/decorative" val="1"/>
-              </a:ext>
-            </a:extLst>
-          </p:cNvPr>
-          <p:cNvSpPr>
-            <a:spLocks noGrp="1" noRot="1" noChangeAspect="1" noMove="1" noResize="1" noEditPoints="1" noAdjustHandles="1" noChangeArrowheads="1" noChangeShapeType="1" noTextEdit="1"/>
-          </p:cNvSpPr>
-          <p:nvPr>
-            <p:extLst>
-              <p:ext uri="{386F3935-93C4-4BCD-93E2-E3B085C9AB24}">
-                <p16:designElem xmlns:p16="http://schemas.microsoft.com/office/powerpoint/2015/main" val="1"/>
-              </p:ext>
-            </p:extLst>
-          </p:nvPr>
-        </p:nvSpPr>
-        <p:spPr>
-          <a:xfrm>
-            <a:off x="395893" y="2443480"/>
-            <a:ext cx="3383280" cy="18288"/>
-          </a:xfrm>
-          <a:prstGeom prst="rect">
-            <a:avLst/>
-          </a:prstGeom>
-          <a:solidFill>
-            <a:schemeClr val="tx2">
-              <a:lumMod val="25000"/>
-              <a:lumOff val="75000"/>
-            </a:schemeClr>
-          </a:solidFill>
-          <a:ln w="3175">
-            <a:noFill/>
-          </a:ln>
-          <a:effectLst/>
-        </p:spPr>
-        <p:style>
-          <a:lnRef idx="2">
-            <a:schemeClr val="accent1">
-              <a:shade val="50000"/>
-            </a:schemeClr>
-          </a:lnRef>
-          <a:fillRef idx="1">
-            <a:schemeClr val="accent1"/>
-          </a:fillRef>
-          <a:effectRef idx="0">
-            <a:schemeClr val="accent1"/>
-          </a:effectRef>
-          <a:fontRef idx="minor">
-            <a:schemeClr val="lt1"/>
-          </a:fontRef>
-        </p:style>
-        <p:txBody>
-          <a:bodyPr rtlCol="0" anchor="ctr"/>
-          <a:lstStyle/>
-          <a:p>
-            <a:pPr marL="0" marR="0" lvl="0" indent="0" algn="ctr" defTabSz="914400" rtl="0" eaLnBrk="1" fontAlgn="auto" latinLnBrk="0" hangingPunct="1">
-              <a:lnSpc>
-                <a:spcPct val="100000"/>
-              </a:lnSpc>
-              <a:spcBef>
-                <a:spcPts val="0"/>
-              </a:spcBef>
-              <a:spcAft>
-                <a:spcPts val="0"/>
-              </a:spcAft>
-              <a:buClrTx/>
-              <a:buSzTx/>
-              <a:buFontTx/>
-              <a:buNone/>
-              <a:tabLst/>
-              <a:defRPr/>
-            </a:pPr>
-            <a:endParaRPr kumimoji="0" lang="en-US" sz="1800" b="0" i="0" u="none" strike="noStrike" kern="1200" cap="none" spc="0" normalizeH="0" baseline="0" noProof="0">
-              <a:ln>
-                <a:noFill/>
-              </a:ln>
-              <a:solidFill>
-                <a:prstClr val="white"/>
-              </a:solidFill>
-              <a:effectLst/>
-              <a:uLnTx/>
-              <a:uFillTx/>
-              <a:latin typeface="Calibri" panose="020F0502020204030204"/>
-              <a:ea typeface="+mn-ea"/>
-              <a:cs typeface="+mn-cs"/>
-            </a:endParaRPr>
-          </a:p>
-        </p:txBody>
-      </p:sp>
-      <p:sp>
-        <p:nvSpPr>
-          <p:cNvPr id="3" name="Content Placeholder 2">
-            <a:extLst>
-              <a:ext uri="{FF2B5EF4-FFF2-40B4-BE49-F238E27FC236}">
-                <a16:creationId xmlns:a16="http://schemas.microsoft.com/office/drawing/2014/main" id="{1221E3C7-935B-EB2C-41DA-2AC861B02636}"/>
-              </a:ext>
-            </a:extLst>
-          </p:cNvPr>
-          <p:cNvSpPr>
-            <a:spLocks noGrp="1"/>
-          </p:cNvSpPr>
-          <p:nvPr>
-            <p:ph idx="1"/>
-          </p:nvPr>
-        </p:nvSpPr>
-        <p:spPr>
-          <a:xfrm>
-            <a:off x="371094" y="2718054"/>
-            <a:ext cx="3438906" cy="3207258"/>
-          </a:xfrm>
-        </p:spPr>
-        <p:txBody>
-          <a:bodyPr anchor="t">
-            <a:normAutofit/>
-          </a:bodyPr>
-          <a:lstStyle/>
-          <a:p>
-            <a:r>
-              <a:rPr lang="en-US" sz="1700" dirty="0"/>
-              <a:t>ShadCN – Customizable Component library (</a:t>
-            </a:r>
-            <a:r>
-              <a:rPr lang="en-US" sz="1700" dirty="0">
-                <a:hlinkClick r:id="rId2"/>
-              </a:rPr>
-              <a:t>https://ui.shadcn.com/</a:t>
-            </a:r>
-            <a:r>
-              <a:rPr lang="en-US" sz="1700" dirty="0"/>
-              <a:t>)</a:t>
-            </a:r>
-          </a:p>
-          <a:p>
-            <a:r>
-              <a:rPr lang="en-US" sz="1700" dirty="0" err="1"/>
-              <a:t>AnimateUI</a:t>
-            </a:r>
-            <a:r>
-              <a:rPr lang="en-US" sz="1700" dirty="0"/>
-              <a:t> – Extension of ShadCN offering animated components (</a:t>
-            </a:r>
-            <a:r>
-              <a:rPr lang="en-US" sz="1700" dirty="0">
-                <a:hlinkClick r:id="rId3"/>
-              </a:rPr>
-              <a:t>https://www.shadcn.io/template/animate-ui-animate-ui</a:t>
-            </a:r>
-            <a:r>
-              <a:rPr lang="en-US" sz="1700" dirty="0"/>
-              <a:t>)</a:t>
-            </a:r>
-          </a:p>
-          <a:p>
-            <a:endParaRPr lang="en-US" sz="1700" dirty="0"/>
-          </a:p>
-          <a:p>
-            <a:endParaRPr lang="en-US" sz="1700" dirty="0"/>
-          </a:p>
-        </p:txBody>
-      </p:sp>
       <p:pic>
         <p:nvPicPr>
-          <p:cNvPr id="5" name="Picture 4" descr="A screen shot of a computer program&#10;&#10;AI-generated content may be incorrect.">
-            <a:extLst>
-              <a:ext uri="{FF2B5EF4-FFF2-40B4-BE49-F238E27FC236}">
-                <a16:creationId xmlns:a16="http://schemas.microsoft.com/office/drawing/2014/main" id="{B2CC4308-0F7B-F7F1-E7CA-38BD50DEC1A9}"/>
+          <p:cNvPr id="4" name="Picture 3" descr="A screenshot of a web page&#10;&#10;AI-generated content may be incorrect.">
+            <a:extLst>
+              <a:ext uri="{FF2B5EF4-FFF2-40B4-BE49-F238E27FC236}">
+                <a16:creationId xmlns:a16="http://schemas.microsoft.com/office/drawing/2014/main" id="{50862488-C2A7-56BA-7293-C7EB907526B9}"/>
               </a:ext>
             </a:extLst>
           </p:cNvPr>
@@ -12302,61 +12154,25 @@
           <p:nvPr/>
         </p:nvPicPr>
         <p:blipFill>
-          <a:blip r:embed="rId4"/>
+          <a:blip r:embed="rId3"/>
           <a:stretch>
             <a:fillRect/>
           </a:stretch>
         </p:blipFill>
         <p:spPr>
           <a:xfrm>
-            <a:off x="4898898" y="1426546"/>
-            <a:ext cx="6922008" cy="3132207"/>
+            <a:off x="679545" y="2266813"/>
+            <a:ext cx="6378574" cy="3862350"/>
           </a:xfrm>
           <a:prstGeom prst="rect">
             <a:avLst/>
           </a:prstGeom>
         </p:spPr>
       </p:pic>
-      <p:sp>
-        <p:nvSpPr>
-          <p:cNvPr id="6" name="TextBox 5">
-            <a:extLst>
-              <a:ext uri="{FF2B5EF4-FFF2-40B4-BE49-F238E27FC236}">
-                <a16:creationId xmlns:a16="http://schemas.microsoft.com/office/drawing/2014/main" id="{615FF795-D189-52AF-4F44-45A167668A2C}"/>
-              </a:ext>
-            </a:extLst>
-          </p:cNvPr>
-          <p:cNvSpPr txBox="1"/>
-          <p:nvPr/>
-        </p:nvSpPr>
-        <p:spPr>
-          <a:xfrm>
-            <a:off x="4898899" y="4596279"/>
-            <a:ext cx="6922007" cy="646331"/>
-          </a:xfrm>
-          <a:prstGeom prst="rect">
-            <a:avLst/>
-          </a:prstGeom>
-          <a:noFill/>
-        </p:spPr>
-        <p:txBody>
-          <a:bodyPr wrap="square" rtlCol="0">
-            <a:spAutoFit/>
-          </a:bodyPr>
-          <a:lstStyle/>
-          <a:p>
-            <a:pPr algn="ctr"/>
-            <a:r>
-              <a:rPr lang="en-US" dirty="0"/>
-              <a:t>Only installs modules you specifically download, and allows complete control / customization</a:t>
-            </a:r>
-          </a:p>
-        </p:txBody>
-      </p:sp>
     </p:spTree>
     <p:extLst>
       <p:ext uri="{BB962C8B-B14F-4D97-AF65-F5344CB8AC3E}">
-        <p14:creationId xmlns:p14="http://schemas.microsoft.com/office/powerpoint/2010/main" val="3611386767"/>
+        <p14:creationId xmlns:p14="http://schemas.microsoft.com/office/powerpoint/2010/main" val="3687148187"/>
       </p:ext>
     </p:extLst>
   </p:cSld>

</xml_diff>